<commit_message>
Latest slide AHV Data Hack 2026
</commit_message>
<xml_diff>
--- a/slides/Dr. Aditya Bhattacharya_new .pptx
+++ b/slides/Dr. Aditya Bhattacharya_new .pptx
@@ -16,7 +16,7 @@
     <p:sldId id="270" r:id="rId7"/>
     <p:sldId id="271" r:id="rId8"/>
     <p:sldId id="272" r:id="rId9"/>
-    <p:sldId id="273" r:id="rId10"/>
+    <p:sldId id="297" r:id="rId10"/>
     <p:sldId id="295" r:id="rId11"/>
     <p:sldId id="274" r:id="rId12"/>
     <p:sldId id="275" r:id="rId13"/>
@@ -227,7 +227,7 @@
           </a:lstStyle>
           <a:p>
             <a:fld id="{ACD8CC80-46D1-4B6F-9086-510E80774687}" type="datetimeFigureOut">
-              <a:t>6/28/2026</a:t>
+              <a:t>7/23/2026</a:t>
             </a:fld>
             <a:endParaRPr lang="en-US"/>
           </a:p>
@@ -4447,7 +4447,7 @@
         <p:cNvPr id="1" name="">
           <a:extLst>
             <a:ext uri="{FF2B5EF4-FFF2-40B4-BE49-F238E27FC236}">
-              <a16:creationId xmlns:a16="http://schemas.microsoft.com/office/drawing/2014/main" id="{A9B2F96C-FD5E-B521-E379-6469ED050147}"/>
+              <a16:creationId xmlns:a16="http://schemas.microsoft.com/office/drawing/2014/main" id="{46FE2039-D804-95E5-0739-E8125BCB555D}"/>
             </a:ext>
           </a:extLst>
         </p:cNvPr>
@@ -4467,7 +4467,7 @@
           <p:cNvPr id="2" name="Slide Image Placeholder 1">
             <a:extLst>
               <a:ext uri="{FF2B5EF4-FFF2-40B4-BE49-F238E27FC236}">
-                <a16:creationId xmlns:a16="http://schemas.microsoft.com/office/drawing/2014/main" id="{C0861402-1770-E7D8-7D71-EA468D416F5B}"/>
+                <a16:creationId xmlns:a16="http://schemas.microsoft.com/office/drawing/2014/main" id="{B65FCEE7-31EF-AA17-09ED-82DF44FFF9DC}"/>
               </a:ext>
             </a:extLst>
           </p:cNvPr>
@@ -4485,7 +4485,7 @@
           <p:cNvPr id="3" name="Notes Placeholder 2">
             <a:extLst>
               <a:ext uri="{FF2B5EF4-FFF2-40B4-BE49-F238E27FC236}">
-                <a16:creationId xmlns:a16="http://schemas.microsoft.com/office/drawing/2014/main" id="{11D07C53-A11D-FA7C-6B50-96425484A537}"/>
+                <a16:creationId xmlns:a16="http://schemas.microsoft.com/office/drawing/2014/main" id="{A0B72D20-F818-E671-358A-97E903D527FF}"/>
               </a:ext>
             </a:extLst>
           </p:cNvPr>
@@ -4510,7 +4510,7 @@
           <p:cNvPr id="4" name="Slide Number Placeholder 3">
             <a:extLst>
               <a:ext uri="{FF2B5EF4-FFF2-40B4-BE49-F238E27FC236}">
-                <a16:creationId xmlns:a16="http://schemas.microsoft.com/office/drawing/2014/main" id="{63D59B77-825D-2775-24B7-2482ED0B2022}"/>
+                <a16:creationId xmlns:a16="http://schemas.microsoft.com/office/drawing/2014/main" id="{B2339C39-1C15-0880-0556-EAFC7ECB361B}"/>
               </a:ext>
             </a:extLst>
           </p:cNvPr>
@@ -4537,7 +4537,7 @@
     </p:spTree>
     <p:extLst>
       <p:ext uri="{BB962C8B-B14F-4D97-AF65-F5344CB8AC3E}">
-        <p14:creationId xmlns:p14="http://schemas.microsoft.com/office/powerpoint/2010/main" val="3008932601"/>
+        <p14:creationId xmlns:p14="http://schemas.microsoft.com/office/powerpoint/2010/main" val="2865564872"/>
       </p:ext>
     </p:extLst>
   </p:cSld>
@@ -5962,6 +5962,66 @@
           </a:prstGeom>
         </p:spPr>
       </p:pic>
+      <p:pic>
+        <p:nvPicPr>
+          <p:cNvPr id="7" name="Picture 6">
+            <a:extLst>
+              <a:ext uri="{FF2B5EF4-FFF2-40B4-BE49-F238E27FC236}">
+                <a16:creationId xmlns:a16="http://schemas.microsoft.com/office/drawing/2014/main" id="{932C7970-D43F-E883-BD72-E999BA3DF156}"/>
+              </a:ext>
+            </a:extLst>
+          </p:cNvPr>
+          <p:cNvPicPr>
+            <a:picLocks noChangeAspect="1"/>
+          </p:cNvPicPr>
+          <p:nvPr/>
+        </p:nvPicPr>
+        <p:blipFill>
+          <a:blip r:embed="rId5"/>
+          <a:stretch>
+            <a:fillRect/>
+          </a:stretch>
+        </p:blipFill>
+        <p:spPr>
+          <a:xfrm>
+            <a:off x="1451945" y="1585752"/>
+            <a:ext cx="8950090" cy="2425139"/>
+          </a:xfrm>
+          <a:prstGeom prst="rect">
+            <a:avLst/>
+          </a:prstGeom>
+        </p:spPr>
+      </p:pic>
+      <p:pic>
+        <p:nvPicPr>
+          <p:cNvPr id="9" name="Picture 8">
+            <a:extLst>
+              <a:ext uri="{FF2B5EF4-FFF2-40B4-BE49-F238E27FC236}">
+                <a16:creationId xmlns:a16="http://schemas.microsoft.com/office/drawing/2014/main" id="{9F61F60F-3B21-5483-5E24-CB46C2AAA758}"/>
+              </a:ext>
+            </a:extLst>
+          </p:cNvPr>
+          <p:cNvPicPr>
+            <a:picLocks noChangeAspect="1"/>
+          </p:cNvPicPr>
+          <p:nvPr/>
+        </p:nvPicPr>
+        <p:blipFill>
+          <a:blip r:embed="rId6"/>
+          <a:stretch>
+            <a:fillRect/>
+          </a:stretch>
+        </p:blipFill>
+        <p:spPr>
+          <a:xfrm>
+            <a:off x="1561866" y="4243331"/>
+            <a:ext cx="8840169" cy="2457399"/>
+          </a:xfrm>
+          <a:prstGeom prst="rect">
+            <a:avLst/>
+          </a:prstGeom>
+        </p:spPr>
+      </p:pic>
     </p:spTree>
     <p:extLst>
       <p:ext uri="{BB962C8B-B14F-4D97-AF65-F5344CB8AC3E}">
@@ -6006,6 +6066,36 @@
           <a:chExt cx="0" cy="0"/>
         </a:xfrm>
       </p:grpSpPr>
+      <p:pic>
+        <p:nvPicPr>
+          <p:cNvPr id="10" name="Picture 9">
+            <a:extLst>
+              <a:ext uri="{FF2B5EF4-FFF2-40B4-BE49-F238E27FC236}">
+                <a16:creationId xmlns:a16="http://schemas.microsoft.com/office/drawing/2014/main" id="{82D66C00-7FE4-3B2A-3044-00B84DA4492E}"/>
+              </a:ext>
+            </a:extLst>
+          </p:cNvPr>
+          <p:cNvPicPr>
+            <a:picLocks noChangeAspect="1"/>
+          </p:cNvPicPr>
+          <p:nvPr/>
+        </p:nvPicPr>
+        <p:blipFill>
+          <a:blip r:embed="rId3"/>
+          <a:stretch>
+            <a:fillRect/>
+          </a:stretch>
+        </p:blipFill>
+        <p:spPr>
+          <a:xfrm>
+            <a:off x="731520" y="3169227"/>
+            <a:ext cx="10375840" cy="3313869"/>
+          </a:xfrm>
+          <a:prstGeom prst="rect">
+            <a:avLst/>
+          </a:prstGeom>
+        </p:spPr>
+      </p:pic>
       <p:sp>
         <p:nvSpPr>
           <p:cNvPr id="2" name="Shape 0">
@@ -6130,7 +6220,7 @@
         </p:nvSpPr>
         <p:spPr>
           <a:xfrm>
-            <a:off x="566928" y="1761374"/>
+            <a:off x="585216" y="1578134"/>
             <a:ext cx="146304" cy="146304"/>
           </a:xfrm>
           <a:prstGeom prst="ellipse">
@@ -6163,7 +6253,7 @@
         </p:nvSpPr>
         <p:spPr>
           <a:xfrm>
-            <a:off x="914399" y="1642502"/>
+            <a:off x="932687" y="1459262"/>
             <a:ext cx="8728364" cy="868680"/>
           </a:xfrm>
           <a:prstGeom prst="rect">
@@ -6222,7 +6312,7 @@
         </p:nvSpPr>
         <p:spPr>
           <a:xfrm>
-            <a:off x="566928" y="2435262"/>
+            <a:off x="585216" y="2252022"/>
             <a:ext cx="146304" cy="146304"/>
           </a:xfrm>
           <a:prstGeom prst="ellipse">
@@ -6255,7 +6345,7 @@
         </p:nvSpPr>
         <p:spPr>
           <a:xfrm>
-            <a:off x="914399" y="2316390"/>
+            <a:off x="932687" y="2133150"/>
             <a:ext cx="8728363" cy="1109586"/>
           </a:xfrm>
           <a:prstGeom prst="rect">
@@ -6376,7 +6466,7 @@
           <p:nvPr/>
         </p:nvPicPr>
         <p:blipFill>
-          <a:blip r:embed="rId3"/>
+          <a:blip r:embed="rId4"/>
           <a:srcRect b="-176"/>
           <a:stretch>
             <a:fillRect/>
@@ -6390,42 +6480,6 @@
           <a:prstGeom prst="rect">
             <a:avLst/>
           </a:prstGeom>
-        </p:spPr>
-      </p:pic>
-      <p:pic>
-        <p:nvPicPr>
-          <p:cNvPr id="12" name="Picture 11">
-            <a:extLst>
-              <a:ext uri="{FF2B5EF4-FFF2-40B4-BE49-F238E27FC236}">
-                <a16:creationId xmlns:a16="http://schemas.microsoft.com/office/drawing/2014/main" id="{C3CD77AC-6C6C-F2CB-0B9F-E094C6442E6D}"/>
-              </a:ext>
-            </a:extLst>
-          </p:cNvPr>
-          <p:cNvPicPr>
-            <a:picLocks noChangeAspect="1"/>
-          </p:cNvPicPr>
-          <p:nvPr/>
-        </p:nvPicPr>
-        <p:blipFill>
-          <a:blip r:embed="rId4"/>
-          <a:srcRect b="49793"/>
-          <a:stretch>
-            <a:fillRect/>
-          </a:stretch>
-        </p:blipFill>
-        <p:spPr>
-          <a:xfrm>
-            <a:off x="692729" y="3385528"/>
-            <a:ext cx="8950034" cy="2910839"/>
-          </a:xfrm>
-          <a:prstGeom prst="rect">
-            <a:avLst/>
-          </a:prstGeom>
-          <a:ln>
-            <a:solidFill>
-              <a:schemeClr val="bg1"/>
-            </a:solidFill>
-          </a:ln>
         </p:spPr>
       </p:pic>
     </p:spTree>
@@ -6472,42 +6526,6 @@
           <a:chExt cx="0" cy="0"/>
         </a:xfrm>
       </p:grpSpPr>
-      <p:pic>
-        <p:nvPicPr>
-          <p:cNvPr id="5" name="Picture 4">
-            <a:extLst>
-              <a:ext uri="{FF2B5EF4-FFF2-40B4-BE49-F238E27FC236}">
-                <a16:creationId xmlns:a16="http://schemas.microsoft.com/office/drawing/2014/main" id="{71B31902-73A4-6A3F-D120-BB0532422C01}"/>
-              </a:ext>
-            </a:extLst>
-          </p:cNvPr>
-          <p:cNvPicPr>
-            <a:picLocks noChangeAspect="1"/>
-          </p:cNvPicPr>
-          <p:nvPr/>
-        </p:nvPicPr>
-        <p:blipFill>
-          <a:blip r:embed="rId3"/>
-          <a:srcRect t="50337" b="-544"/>
-          <a:stretch>
-            <a:fillRect/>
-          </a:stretch>
-        </p:blipFill>
-        <p:spPr>
-          <a:xfrm>
-            <a:off x="692729" y="3425976"/>
-            <a:ext cx="8950034" cy="2910839"/>
-          </a:xfrm>
-          <a:prstGeom prst="rect">
-            <a:avLst/>
-          </a:prstGeom>
-          <a:ln>
-            <a:solidFill>
-              <a:schemeClr val="bg1"/>
-            </a:solidFill>
-          </a:ln>
-        </p:spPr>
-      </p:pic>
       <p:sp>
         <p:nvSpPr>
           <p:cNvPr id="2" name="Shape 0">
@@ -6632,7 +6650,7 @@
         </p:nvSpPr>
         <p:spPr>
           <a:xfrm>
-            <a:off x="566928" y="1761374"/>
+            <a:off x="566928" y="1578134"/>
             <a:ext cx="146304" cy="146304"/>
           </a:xfrm>
           <a:prstGeom prst="ellipse">
@@ -6665,7 +6683,7 @@
         </p:nvSpPr>
         <p:spPr>
           <a:xfrm>
-            <a:off x="914399" y="1642502"/>
+            <a:off x="914399" y="1459262"/>
             <a:ext cx="8728364" cy="868680"/>
           </a:xfrm>
           <a:prstGeom prst="rect">
@@ -6740,7 +6758,7 @@
         </p:nvSpPr>
         <p:spPr>
           <a:xfrm>
-            <a:off x="566928" y="2435262"/>
+            <a:off x="566928" y="2252022"/>
             <a:ext cx="146304" cy="146304"/>
           </a:xfrm>
           <a:prstGeom prst="ellipse">
@@ -6773,7 +6791,7 @@
         </p:nvSpPr>
         <p:spPr>
           <a:xfrm>
-            <a:off x="914399" y="2316390"/>
+            <a:off x="914399" y="2133150"/>
             <a:ext cx="8728363" cy="1109586"/>
           </a:xfrm>
           <a:prstGeom prst="rect">
@@ -6878,7 +6896,7 @@
           <p:nvPr/>
         </p:nvPicPr>
         <p:blipFill>
-          <a:blip r:embed="rId4"/>
+          <a:blip r:embed="rId3"/>
           <a:srcRect b="-176"/>
           <a:stretch>
             <a:fillRect/>
@@ -6888,6 +6906,36 @@
           <a:xfrm>
             <a:off x="10792419" y="367621"/>
             <a:ext cx="852695" cy="852309"/>
+          </a:xfrm>
+          <a:prstGeom prst="rect">
+            <a:avLst/>
+          </a:prstGeom>
+        </p:spPr>
+      </p:pic>
+      <p:pic>
+        <p:nvPicPr>
+          <p:cNvPr id="11" name="Picture 10">
+            <a:extLst>
+              <a:ext uri="{FF2B5EF4-FFF2-40B4-BE49-F238E27FC236}">
+                <a16:creationId xmlns:a16="http://schemas.microsoft.com/office/drawing/2014/main" id="{20F41853-753F-46A9-1BF6-59FC3B4CE13A}"/>
+              </a:ext>
+            </a:extLst>
+          </p:cNvPr>
+          <p:cNvPicPr>
+            <a:picLocks noChangeAspect="1"/>
+          </p:cNvPicPr>
+          <p:nvPr/>
+        </p:nvPicPr>
+        <p:blipFill>
+          <a:blip r:embed="rId4"/>
+          <a:stretch>
+            <a:fillRect/>
+          </a:stretch>
+        </p:blipFill>
+        <p:spPr>
+          <a:xfrm>
+            <a:off x="544068" y="2979808"/>
+            <a:ext cx="10906298" cy="3302120"/>
           </a:xfrm>
           <a:prstGeom prst="rect">
             <a:avLst/>
@@ -7473,10 +7521,10 @@
       </p:grpSp>
       <p:pic>
         <p:nvPicPr>
-          <p:cNvPr id="16" name="Picture 15">
-            <a:extLst>
-              <a:ext uri="{FF2B5EF4-FFF2-40B4-BE49-F238E27FC236}">
-                <a16:creationId xmlns:a16="http://schemas.microsoft.com/office/drawing/2014/main" id="{3D51113E-496D-92CE-6233-AF187D4A75A5}"/>
+          <p:cNvPr id="17" name="Picture 16">
+            <a:extLst>
+              <a:ext uri="{FF2B5EF4-FFF2-40B4-BE49-F238E27FC236}">
+                <a16:creationId xmlns:a16="http://schemas.microsoft.com/office/drawing/2014/main" id="{1F843B6A-B849-19CE-791C-344C94C57E56}"/>
               </a:ext>
             </a:extLst>
           </p:cNvPr>
@@ -7493,20 +7541,12 @@
         </p:blipFill>
         <p:spPr>
           <a:xfrm>
-            <a:off x="585216" y="3122177"/>
-            <a:ext cx="10248797" cy="3010624"/>
-          </a:xfrm>
-          <a:prstGeom prst="rect">
-            <a:avLst/>
-          </a:prstGeom>
-          <a:solidFill>
-            <a:schemeClr val="bg2"/>
-          </a:solidFill>
-          <a:ln>
-            <a:solidFill>
-              <a:schemeClr val="bg1"/>
-            </a:solidFill>
-          </a:ln>
+            <a:off x="47482" y="3039021"/>
+            <a:ext cx="12093988" cy="3063505"/>
+          </a:xfrm>
+          <a:prstGeom prst="rect">
+            <a:avLst/>
+          </a:prstGeom>
         </p:spPr>
       </p:pic>
     </p:spTree>
@@ -8313,6 +8353,36 @@
           <a:chExt cx="0" cy="0"/>
         </a:xfrm>
       </p:grpSpPr>
+      <p:pic>
+        <p:nvPicPr>
+          <p:cNvPr id="7" name="Picture 6">
+            <a:extLst>
+              <a:ext uri="{FF2B5EF4-FFF2-40B4-BE49-F238E27FC236}">
+                <a16:creationId xmlns:a16="http://schemas.microsoft.com/office/drawing/2014/main" id="{BE1BC0A5-0AF9-BAB9-B835-8864DE74381F}"/>
+              </a:ext>
+            </a:extLst>
+          </p:cNvPr>
+          <p:cNvPicPr>
+            <a:picLocks noChangeAspect="1"/>
+          </p:cNvPicPr>
+          <p:nvPr/>
+        </p:nvPicPr>
+        <p:blipFill>
+          <a:blip r:embed="rId3"/>
+          <a:stretch>
+            <a:fillRect/>
+          </a:stretch>
+        </p:blipFill>
+        <p:spPr>
+          <a:xfrm>
+            <a:off x="686295" y="1632710"/>
+            <a:ext cx="10958819" cy="4850386"/>
+          </a:xfrm>
+          <a:prstGeom prst="rect">
+            <a:avLst/>
+          </a:prstGeom>
+        </p:spPr>
+      </p:pic>
       <p:sp>
         <p:nvSpPr>
           <p:cNvPr id="2" name="Shape 0">
@@ -8483,7 +8553,7 @@
           <p:nvPr/>
         </p:nvPicPr>
         <p:blipFill>
-          <a:blip r:embed="rId3"/>
+          <a:blip r:embed="rId4"/>
           <a:srcRect b="-176"/>
           <a:stretch>
             <a:fillRect/>
@@ -8513,7 +8583,7 @@
         </p:nvSpPr>
         <p:spPr>
           <a:xfrm>
-            <a:off x="512064" y="1417320"/>
+            <a:off x="502920" y="1289810"/>
             <a:ext cx="8686800" cy="411480"/>
           </a:xfrm>
           <a:prstGeom prst="rect">
@@ -8543,41 +8613,6 @@
           </a:p>
         </p:txBody>
       </p:sp>
-      <p:pic>
-        <p:nvPicPr>
-          <p:cNvPr id="5" name="Picture 4">
-            <a:extLst>
-              <a:ext uri="{FF2B5EF4-FFF2-40B4-BE49-F238E27FC236}">
-                <a16:creationId xmlns:a16="http://schemas.microsoft.com/office/drawing/2014/main" id="{57966B2B-D7FB-26F0-6D2A-3B585524EEC2}"/>
-              </a:ext>
-            </a:extLst>
-          </p:cNvPr>
-          <p:cNvPicPr>
-            <a:picLocks noChangeAspect="1"/>
-          </p:cNvPicPr>
-          <p:nvPr/>
-        </p:nvPicPr>
-        <p:blipFill>
-          <a:blip r:embed="rId4"/>
-          <a:stretch>
-            <a:fillRect/>
-          </a:stretch>
-        </p:blipFill>
-        <p:spPr>
-          <a:xfrm>
-            <a:off x="512064" y="1866615"/>
-            <a:ext cx="10245852" cy="4598009"/>
-          </a:xfrm>
-          <a:prstGeom prst="rect">
-            <a:avLst/>
-          </a:prstGeom>
-          <a:ln>
-            <a:solidFill>
-              <a:schemeClr val="bg1"/>
-            </a:solidFill>
-          </a:ln>
-        </p:spPr>
-      </p:pic>
     </p:spTree>
     <p:extLst>
       <p:ext uri="{BB962C8B-B14F-4D97-AF65-F5344CB8AC3E}">
@@ -8624,10 +8659,10 @@
       </p:grpSpPr>
       <p:pic>
         <p:nvPicPr>
-          <p:cNvPr id="6" name="Picture 5">
-            <a:extLst>
-              <a:ext uri="{FF2B5EF4-FFF2-40B4-BE49-F238E27FC236}">
-                <a16:creationId xmlns:a16="http://schemas.microsoft.com/office/drawing/2014/main" id="{11B08909-BAE4-6ACC-90DB-E79762FF7130}"/>
+          <p:cNvPr id="7" name="Picture 6">
+            <a:extLst>
+              <a:ext uri="{FF2B5EF4-FFF2-40B4-BE49-F238E27FC236}">
+                <a16:creationId xmlns:a16="http://schemas.microsoft.com/office/drawing/2014/main" id="{6FFBBFE9-A6C3-0306-D7C6-BBFC3F4F6C72}"/>
               </a:ext>
             </a:extLst>
           </p:cNvPr>
@@ -8644,17 +8679,12 @@
         </p:blipFill>
         <p:spPr>
           <a:xfrm>
-            <a:off x="834598" y="1677168"/>
-            <a:ext cx="9824166" cy="4805928"/>
-          </a:xfrm>
-          <a:prstGeom prst="rect">
-            <a:avLst/>
-          </a:prstGeom>
-          <a:ln>
-            <a:solidFill>
-              <a:schemeClr val="bg1"/>
-            </a:solidFill>
-          </a:ln>
+            <a:off x="700756" y="1527842"/>
+            <a:ext cx="10787440" cy="5169722"/>
+          </a:xfrm>
+          <a:prstGeom prst="rect">
+            <a:avLst/>
+          </a:prstGeom>
         </p:spPr>
       </p:pic>
       <p:sp>
@@ -8764,51 +8794,6 @@
           <a:lstStyle/>
           <a:p>
             <a:endParaRPr lang="en-US"/>
-          </a:p>
-        </p:txBody>
-      </p:sp>
-      <p:sp>
-        <p:nvSpPr>
-          <p:cNvPr id="11" name="Text 7">
-            <a:extLst>
-              <a:ext uri="{FF2B5EF4-FFF2-40B4-BE49-F238E27FC236}">
-                <a16:creationId xmlns:a16="http://schemas.microsoft.com/office/drawing/2014/main" id="{0751DA82-8C63-8703-6FA9-FD18CC129846}"/>
-              </a:ext>
-            </a:extLst>
-          </p:cNvPr>
-          <p:cNvSpPr/>
-          <p:nvPr/>
-        </p:nvSpPr>
-        <p:spPr>
-          <a:xfrm>
-            <a:off x="0" y="6419088"/>
-            <a:ext cx="12191695" cy="320040"/>
-          </a:xfrm>
-          <a:prstGeom prst="rect">
-            <a:avLst/>
-          </a:prstGeom>
-          <a:noFill/>
-          <a:ln/>
-        </p:spPr>
-        <p:txBody>
-          <a:bodyPr wrap="square" lIns="0" tIns="0" rIns="0" bIns="0" rtlCol="0" anchor="ctr"/>
-          <a:lstStyle/>
-          <a:p>
-            <a:pPr marL="0" indent="0" algn="ctr">
-              <a:buNone/>
-            </a:pPr>
-            <a:r>
-              <a:rPr lang="en-US" sz="950" kern="0" spc="200">
-                <a:solidFill>
-                  <a:srgbClr val="8A93A8"/>
-                </a:solidFill>
-                <a:latin typeface="Arial" pitchFamily="34" charset="0"/>
-                <a:ea typeface="Arial" pitchFamily="34" charset="-122"/>
-                <a:cs typeface="Arial" pitchFamily="34" charset="-120"/>
-              </a:rPr>
-              <a:t>D A T A H A C K   S U M M I T   2 0 2 6</a:t>
-            </a:r>
-            <a:endParaRPr lang="en-US" sz="950"/>
           </a:p>
         </p:txBody>
       </p:sp>
@@ -8857,7 +8842,7 @@
         </p:nvSpPr>
         <p:spPr>
           <a:xfrm>
-            <a:off x="512064" y="1417320"/>
+            <a:off x="502920" y="1322102"/>
             <a:ext cx="8686800" cy="411480"/>
           </a:xfrm>
           <a:prstGeom prst="rect">
@@ -8931,6 +8916,41 @@
           <a:chExt cx="0" cy="0"/>
         </a:xfrm>
       </p:grpSpPr>
+      <p:pic>
+        <p:nvPicPr>
+          <p:cNvPr id="5" name="Picture 4">
+            <a:extLst>
+              <a:ext uri="{FF2B5EF4-FFF2-40B4-BE49-F238E27FC236}">
+                <a16:creationId xmlns:a16="http://schemas.microsoft.com/office/drawing/2014/main" id="{203F269C-7607-9179-68B9-6E6BA1196DFC}"/>
+              </a:ext>
+            </a:extLst>
+          </p:cNvPr>
+          <p:cNvPicPr>
+            <a:picLocks noChangeAspect="1"/>
+          </p:cNvPicPr>
+          <p:nvPr/>
+        </p:nvPicPr>
+        <p:blipFill>
+          <a:blip r:embed="rId3"/>
+          <a:stretch>
+            <a:fillRect/>
+          </a:stretch>
+        </p:blipFill>
+        <p:spPr>
+          <a:xfrm>
+            <a:off x="731520" y="1604276"/>
+            <a:ext cx="10144743" cy="4878820"/>
+          </a:xfrm>
+          <a:prstGeom prst="rect">
+            <a:avLst/>
+          </a:prstGeom>
+          <a:ln>
+            <a:solidFill>
+              <a:schemeClr val="bg1"/>
+            </a:solidFill>
+          </a:ln>
+        </p:spPr>
+      </p:pic>
       <p:sp>
         <p:nvSpPr>
           <p:cNvPr id="2" name="Shape 0">
@@ -9101,7 +9121,7 @@
           <p:nvPr/>
         </p:nvPicPr>
         <p:blipFill>
-          <a:blip r:embed="rId3"/>
+          <a:blip r:embed="rId4"/>
           <a:srcRect b="-176"/>
           <a:stretch>
             <a:fillRect/>
@@ -9131,7 +9151,7 @@
         </p:nvSpPr>
         <p:spPr>
           <a:xfrm>
-            <a:off x="512064" y="1417320"/>
+            <a:off x="502920" y="1325880"/>
             <a:ext cx="8686800" cy="411480"/>
           </a:xfrm>
           <a:prstGeom prst="rect">
@@ -9161,41 +9181,6 @@
           </a:p>
         </p:txBody>
       </p:sp>
-      <p:pic>
-        <p:nvPicPr>
-          <p:cNvPr id="5" name="Picture 4">
-            <a:extLst>
-              <a:ext uri="{FF2B5EF4-FFF2-40B4-BE49-F238E27FC236}">
-                <a16:creationId xmlns:a16="http://schemas.microsoft.com/office/drawing/2014/main" id="{203F269C-7607-9179-68B9-6E6BA1196DFC}"/>
-              </a:ext>
-            </a:extLst>
-          </p:cNvPr>
-          <p:cNvPicPr>
-            <a:picLocks noChangeAspect="1"/>
-          </p:cNvPicPr>
-          <p:nvPr/>
-        </p:nvPicPr>
-        <p:blipFill>
-          <a:blip r:embed="rId4"/>
-          <a:stretch>
-            <a:fillRect/>
-          </a:stretch>
-        </p:blipFill>
-        <p:spPr>
-          <a:xfrm>
-            <a:off x="852076" y="1761756"/>
-            <a:ext cx="9817287" cy="4721340"/>
-          </a:xfrm>
-          <a:prstGeom prst="rect">
-            <a:avLst/>
-          </a:prstGeom>
-          <a:ln>
-            <a:solidFill>
-              <a:schemeClr val="bg1"/>
-            </a:solidFill>
-          </a:ln>
-        </p:spPr>
-      </p:pic>
     </p:spTree>
     <p:extLst>
       <p:ext uri="{BB962C8B-B14F-4D97-AF65-F5344CB8AC3E}">
@@ -9234,142 +9219,15 @@
           <a:chExt cx="0" cy="0"/>
         </a:xfrm>
       </p:grpSpPr>
-      <p:sp>
-        <p:nvSpPr>
-          <p:cNvPr id="2" name="Shape 0"/>
-          <p:cNvSpPr/>
-          <p:nvPr/>
-        </p:nvSpPr>
-        <p:spPr>
-          <a:xfrm>
-            <a:off x="502920" y="548640"/>
-            <a:ext cx="82296" cy="603504"/>
-          </a:xfrm>
-          <a:prstGeom prst="rect">
-            <a:avLst/>
-          </a:prstGeom>
-          <a:solidFill>
-            <a:srgbClr val="FE7202"/>
-          </a:solidFill>
-          <a:ln/>
-        </p:spPr>
-        <p:txBody>
-          <a:bodyPr/>
-          <a:lstStyle/>
-          <a:p>
-            <a:endParaRPr lang="en-US"/>
-          </a:p>
-        </p:txBody>
-      </p:sp>
-      <p:sp>
-        <p:nvSpPr>
-          <p:cNvPr id="3" name="Text 1"/>
-          <p:cNvSpPr/>
-          <p:nvPr/>
-        </p:nvSpPr>
-        <p:spPr>
-          <a:xfrm>
-            <a:off x="731520" y="502920"/>
-            <a:ext cx="10058400" cy="713232"/>
-          </a:xfrm>
-          <a:prstGeom prst="rect">
-            <a:avLst/>
-          </a:prstGeom>
-          <a:noFill/>
-          <a:ln/>
-        </p:spPr>
-        <p:txBody>
-          <a:bodyPr wrap="square" lIns="0" tIns="0" rIns="0" bIns="0" rtlCol="0" anchor="ctr"/>
-          <a:lstStyle/>
-          <a:p>
-            <a:pPr marL="0" indent="0">
-              <a:buNone/>
-            </a:pPr>
-            <a:r>
-              <a:rPr lang="en-US" sz="2900" b="1" dirty="0">
-                <a:solidFill>
-                  <a:srgbClr val="0F2247"/>
-                </a:solidFill>
-                <a:latin typeface="Arial" pitchFamily="34" charset="0"/>
-                <a:ea typeface="Arial" pitchFamily="34" charset="-122"/>
-                <a:cs typeface="Arial" pitchFamily="34" charset="-120"/>
-              </a:rPr>
-              <a:t>Layer 2: Component Level Eval</a:t>
-            </a:r>
-          </a:p>
-        </p:txBody>
-      </p:sp>
-      <p:sp>
-        <p:nvSpPr>
-          <p:cNvPr id="4" name="Shape 2"/>
-          <p:cNvSpPr/>
-          <p:nvPr/>
-        </p:nvSpPr>
-        <p:spPr>
-          <a:xfrm>
-            <a:off x="502920" y="1325880"/>
-            <a:ext cx="11183112" cy="27432"/>
-          </a:xfrm>
-          <a:prstGeom prst="rect">
-            <a:avLst/>
-          </a:prstGeom>
-          <a:solidFill>
-            <a:srgbClr val="FE7202"/>
-          </a:solidFill>
-          <a:ln/>
-        </p:spPr>
-        <p:txBody>
-          <a:bodyPr/>
-          <a:lstStyle/>
-          <a:p>
-            <a:endParaRPr lang="en-US"/>
-          </a:p>
-        </p:txBody>
-      </p:sp>
-      <p:sp>
-        <p:nvSpPr>
-          <p:cNvPr id="8" name="Text 5"/>
-          <p:cNvSpPr/>
-          <p:nvPr/>
-        </p:nvSpPr>
-        <p:spPr>
-          <a:xfrm>
-            <a:off x="6355080" y="1645920"/>
-            <a:ext cx="5303520" cy="685800"/>
-          </a:xfrm>
-          <a:prstGeom prst="rect">
-            <a:avLst/>
-          </a:prstGeom>
-          <a:noFill/>
-          <a:ln/>
-        </p:spPr>
-        <p:txBody>
-          <a:bodyPr wrap="square" lIns="0" tIns="0" rIns="0" bIns="0" rtlCol="0" anchor="ctr"/>
-          <a:lstStyle/>
-          <a:p>
-            <a:pPr marL="0" indent="0">
-              <a:lnSpc>
-                <a:spcPct val="105000"/>
-              </a:lnSpc>
-              <a:buNone/>
-            </a:pPr>
-            <a:r>
-              <a:rPr lang="en-US" sz="2000" b="1" dirty="0">
-                <a:solidFill>
-                  <a:srgbClr val="0F2247"/>
-                </a:solidFill>
-                <a:latin typeface="Arial" pitchFamily="34" charset="0"/>
-                <a:ea typeface="Arial" pitchFamily="34" charset="-122"/>
-                <a:cs typeface="Arial" pitchFamily="34" charset="-120"/>
-              </a:rPr>
-              <a:t>Isn’t E2E eval enough?</a:t>
-            </a:r>
-          </a:p>
-        </p:txBody>
-      </p:sp>
       <p:pic>
         <p:nvPicPr>
-          <p:cNvPr id="10" name="Image 1" descr="/home/claude/dhs/assets2/icons/check.png"/>
+          <p:cNvPr id="18" name="Picture 17">
+            <a:extLst>
+              <a:ext uri="{FF2B5EF4-FFF2-40B4-BE49-F238E27FC236}">
+                <a16:creationId xmlns:a16="http://schemas.microsoft.com/office/drawing/2014/main" id="{F2087C94-5A7B-88D9-C646-24CF0C9D6F61}"/>
+              </a:ext>
+            </a:extLst>
+          </p:cNvPr>
           <p:cNvPicPr>
             <a:picLocks noChangeAspect="1"/>
           </p:cNvPicPr>
@@ -9383,6 +9241,168 @@
         </p:blipFill>
         <p:spPr>
           <a:xfrm>
+            <a:off x="234841" y="1474445"/>
+            <a:ext cx="6084118" cy="4620692"/>
+          </a:xfrm>
+          <a:prstGeom prst="rect">
+            <a:avLst/>
+          </a:prstGeom>
+          <a:ln>
+            <a:solidFill>
+              <a:schemeClr val="bg1"/>
+            </a:solidFill>
+          </a:ln>
+        </p:spPr>
+      </p:pic>
+      <p:sp>
+        <p:nvSpPr>
+          <p:cNvPr id="2" name="Shape 0"/>
+          <p:cNvSpPr/>
+          <p:nvPr/>
+        </p:nvSpPr>
+        <p:spPr>
+          <a:xfrm>
+            <a:off x="502920" y="548640"/>
+            <a:ext cx="82296" cy="603504"/>
+          </a:xfrm>
+          <a:prstGeom prst="rect">
+            <a:avLst/>
+          </a:prstGeom>
+          <a:solidFill>
+            <a:srgbClr val="FE7202"/>
+          </a:solidFill>
+          <a:ln/>
+        </p:spPr>
+        <p:txBody>
+          <a:bodyPr/>
+          <a:lstStyle/>
+          <a:p>
+            <a:endParaRPr lang="en-US"/>
+          </a:p>
+        </p:txBody>
+      </p:sp>
+      <p:sp>
+        <p:nvSpPr>
+          <p:cNvPr id="3" name="Text 1"/>
+          <p:cNvSpPr/>
+          <p:nvPr/>
+        </p:nvSpPr>
+        <p:spPr>
+          <a:xfrm>
+            <a:off x="731520" y="502920"/>
+            <a:ext cx="10058400" cy="713232"/>
+          </a:xfrm>
+          <a:prstGeom prst="rect">
+            <a:avLst/>
+          </a:prstGeom>
+          <a:noFill/>
+          <a:ln/>
+        </p:spPr>
+        <p:txBody>
+          <a:bodyPr wrap="square" lIns="0" tIns="0" rIns="0" bIns="0" rtlCol="0" anchor="ctr"/>
+          <a:lstStyle/>
+          <a:p>
+            <a:pPr marL="0" indent="0">
+              <a:buNone/>
+            </a:pPr>
+            <a:r>
+              <a:rPr lang="en-US" sz="2900" b="1" dirty="0">
+                <a:solidFill>
+                  <a:srgbClr val="0F2247"/>
+                </a:solidFill>
+                <a:latin typeface="Arial" pitchFamily="34" charset="0"/>
+                <a:ea typeface="Arial" pitchFamily="34" charset="-122"/>
+                <a:cs typeface="Arial" pitchFamily="34" charset="-120"/>
+              </a:rPr>
+              <a:t>Layer 2: Component Level Eval</a:t>
+            </a:r>
+          </a:p>
+        </p:txBody>
+      </p:sp>
+      <p:sp>
+        <p:nvSpPr>
+          <p:cNvPr id="4" name="Shape 2"/>
+          <p:cNvSpPr/>
+          <p:nvPr/>
+        </p:nvSpPr>
+        <p:spPr>
+          <a:xfrm>
+            <a:off x="502920" y="1325880"/>
+            <a:ext cx="11183112" cy="27432"/>
+          </a:xfrm>
+          <a:prstGeom prst="rect">
+            <a:avLst/>
+          </a:prstGeom>
+          <a:solidFill>
+            <a:srgbClr val="FE7202"/>
+          </a:solidFill>
+          <a:ln/>
+        </p:spPr>
+        <p:txBody>
+          <a:bodyPr/>
+          <a:lstStyle/>
+          <a:p>
+            <a:endParaRPr lang="en-US"/>
+          </a:p>
+        </p:txBody>
+      </p:sp>
+      <p:sp>
+        <p:nvSpPr>
+          <p:cNvPr id="8" name="Text 5"/>
+          <p:cNvSpPr/>
+          <p:nvPr/>
+        </p:nvSpPr>
+        <p:spPr>
+          <a:xfrm>
+            <a:off x="6355080" y="1645920"/>
+            <a:ext cx="5303520" cy="685800"/>
+          </a:xfrm>
+          <a:prstGeom prst="rect">
+            <a:avLst/>
+          </a:prstGeom>
+          <a:noFill/>
+          <a:ln/>
+        </p:spPr>
+        <p:txBody>
+          <a:bodyPr wrap="square" lIns="0" tIns="0" rIns="0" bIns="0" rtlCol="0" anchor="ctr"/>
+          <a:lstStyle/>
+          <a:p>
+            <a:pPr marL="0" indent="0">
+              <a:lnSpc>
+                <a:spcPct val="105000"/>
+              </a:lnSpc>
+              <a:buNone/>
+            </a:pPr>
+            <a:r>
+              <a:rPr lang="en-US" sz="2000" b="1" dirty="0">
+                <a:solidFill>
+                  <a:srgbClr val="0F2247"/>
+                </a:solidFill>
+                <a:latin typeface="Arial" pitchFamily="34" charset="0"/>
+                <a:ea typeface="Arial" pitchFamily="34" charset="-122"/>
+                <a:cs typeface="Arial" pitchFamily="34" charset="-120"/>
+              </a:rPr>
+              <a:t>Isn’t E2E eval enough?</a:t>
+            </a:r>
+          </a:p>
+        </p:txBody>
+      </p:sp>
+      <p:pic>
+        <p:nvPicPr>
+          <p:cNvPr id="10" name="Image 1" descr="/home/claude/dhs/assets2/icons/check.png"/>
+          <p:cNvPicPr>
+            <a:picLocks noChangeAspect="1"/>
+          </p:cNvPicPr>
+          <p:nvPr/>
+        </p:nvPicPr>
+        <p:blipFill>
+          <a:blip r:embed="rId4"/>
+          <a:stretch>
+            <a:fillRect/>
+          </a:stretch>
+        </p:blipFill>
+        <p:spPr>
+          <a:xfrm>
             <a:off x="6355080" y="2504254"/>
             <a:ext cx="256032" cy="256032"/>
           </a:xfrm>
@@ -9438,7 +9458,7 @@
           <p:nvPr/>
         </p:nvPicPr>
         <p:blipFill>
-          <a:blip r:embed="rId3"/>
+          <a:blip r:embed="rId4"/>
           <a:stretch>
             <a:fillRect/>
           </a:stretch>
@@ -9500,7 +9520,7 @@
           <p:nvPr/>
         </p:nvPicPr>
         <p:blipFill>
-          <a:blip r:embed="rId3"/>
+          <a:blip r:embed="rId4"/>
           <a:stretch>
             <a:fillRect/>
           </a:stretch>
@@ -9607,7 +9627,7 @@
           <p:nvPr/>
         </p:nvPicPr>
         <p:blipFill>
-          <a:blip r:embed="rId4"/>
+          <a:blip r:embed="rId5"/>
           <a:srcRect b="-176"/>
           <a:stretch>
             <a:fillRect/>
@@ -9621,41 +9641,6 @@
           <a:prstGeom prst="rect">
             <a:avLst/>
           </a:prstGeom>
-        </p:spPr>
-      </p:pic>
-      <p:pic>
-        <p:nvPicPr>
-          <p:cNvPr id="18" name="Picture 17">
-            <a:extLst>
-              <a:ext uri="{FF2B5EF4-FFF2-40B4-BE49-F238E27FC236}">
-                <a16:creationId xmlns:a16="http://schemas.microsoft.com/office/drawing/2014/main" id="{F2087C94-5A7B-88D9-C646-24CF0C9D6F61}"/>
-              </a:ext>
-            </a:extLst>
-          </p:cNvPr>
-          <p:cNvPicPr>
-            <a:picLocks noChangeAspect="1"/>
-          </p:cNvPicPr>
-          <p:nvPr/>
-        </p:nvPicPr>
-        <p:blipFill>
-          <a:blip r:embed="rId5"/>
-          <a:stretch>
-            <a:fillRect/>
-          </a:stretch>
-        </p:blipFill>
-        <p:spPr>
-          <a:xfrm>
-            <a:off x="421861" y="1702903"/>
-            <a:ext cx="5674139" cy="4309326"/>
-          </a:xfrm>
-          <a:prstGeom prst="rect">
-            <a:avLst/>
-          </a:prstGeom>
-          <a:ln>
-            <a:solidFill>
-              <a:schemeClr val="bg1"/>
-            </a:solidFill>
-          </a:ln>
         </p:spPr>
       </p:pic>
     </p:spTree>
@@ -10257,10 +10242,10 @@
       </p:pic>
       <p:pic>
         <p:nvPicPr>
-          <p:cNvPr id="9" name="Picture 8">
-            <a:extLst>
-              <a:ext uri="{FF2B5EF4-FFF2-40B4-BE49-F238E27FC236}">
-                <a16:creationId xmlns:a16="http://schemas.microsoft.com/office/drawing/2014/main" id="{757DB22E-D1EB-FFC6-9A26-FD59DEA284C4}"/>
+          <p:cNvPr id="6" name="Picture 5">
+            <a:extLst>
+              <a:ext uri="{FF2B5EF4-FFF2-40B4-BE49-F238E27FC236}">
+                <a16:creationId xmlns:a16="http://schemas.microsoft.com/office/drawing/2014/main" id="{C23710D2-7B9B-1D4A-DA9A-54B91DF8AF67}"/>
               </a:ext>
             </a:extLst>
           </p:cNvPr>
@@ -10277,8 +10262,8 @@
         </p:blipFill>
         <p:spPr>
           <a:xfrm>
-            <a:off x="1688029" y="1929557"/>
-            <a:ext cx="3423190" cy="3423190"/>
+            <a:off x="2033543" y="1883677"/>
+            <a:ext cx="3324700" cy="3324700"/>
           </a:xfrm>
           <a:prstGeom prst="rect">
             <a:avLst/>
@@ -10334,6 +10319,41 @@
           <a:chExt cx="0" cy="0"/>
         </a:xfrm>
       </p:grpSpPr>
+      <p:pic>
+        <p:nvPicPr>
+          <p:cNvPr id="14" name="Picture 13">
+            <a:extLst>
+              <a:ext uri="{FF2B5EF4-FFF2-40B4-BE49-F238E27FC236}">
+                <a16:creationId xmlns:a16="http://schemas.microsoft.com/office/drawing/2014/main" id="{FFD2A173-6183-3DCB-84AE-F7EE206E038A}"/>
+              </a:ext>
+            </a:extLst>
+          </p:cNvPr>
+          <p:cNvPicPr>
+            <a:picLocks noChangeAspect="1"/>
+          </p:cNvPicPr>
+          <p:nvPr/>
+        </p:nvPicPr>
+        <p:blipFill>
+          <a:blip r:embed="rId3"/>
+          <a:stretch>
+            <a:fillRect/>
+          </a:stretch>
+        </p:blipFill>
+        <p:spPr>
+          <a:xfrm>
+            <a:off x="5552723" y="1518338"/>
+            <a:ext cx="6259386" cy="4753802"/>
+          </a:xfrm>
+          <a:prstGeom prst="rect">
+            <a:avLst/>
+          </a:prstGeom>
+          <a:ln>
+            <a:solidFill>
+              <a:schemeClr val="bg2"/>
+            </a:solidFill>
+          </a:ln>
+        </p:spPr>
+      </p:pic>
       <p:sp>
         <p:nvSpPr>
           <p:cNvPr id="2" name="Shape 0">
@@ -10925,7 +10945,7 @@
           <p:nvPr/>
         </p:nvPicPr>
         <p:blipFill>
-          <a:blip r:embed="rId3"/>
+          <a:blip r:embed="rId4"/>
           <a:srcRect b="-176"/>
           <a:stretch>
             <a:fillRect/>
@@ -11042,41 +11062,6 @@
           </a:p>
         </p:txBody>
       </p:sp>
-      <p:pic>
-        <p:nvPicPr>
-          <p:cNvPr id="14" name="Picture 13">
-            <a:extLst>
-              <a:ext uri="{FF2B5EF4-FFF2-40B4-BE49-F238E27FC236}">
-                <a16:creationId xmlns:a16="http://schemas.microsoft.com/office/drawing/2014/main" id="{FFD2A173-6183-3DCB-84AE-F7EE206E038A}"/>
-              </a:ext>
-            </a:extLst>
-          </p:cNvPr>
-          <p:cNvPicPr>
-            <a:picLocks noChangeAspect="1"/>
-          </p:cNvPicPr>
-          <p:nvPr/>
-        </p:nvPicPr>
-        <p:blipFill>
-          <a:blip r:embed="rId4"/>
-          <a:stretch>
-            <a:fillRect/>
-          </a:stretch>
-        </p:blipFill>
-        <p:spPr>
-          <a:xfrm>
-            <a:off x="5907763" y="1619132"/>
-            <a:ext cx="5717309" cy="4342112"/>
-          </a:xfrm>
-          <a:prstGeom prst="rect">
-            <a:avLst/>
-          </a:prstGeom>
-          <a:ln>
-            <a:solidFill>
-              <a:schemeClr val="bg2"/>
-            </a:solidFill>
-          </a:ln>
-        </p:spPr>
-      </p:pic>
     </p:spTree>
     <p:extLst>
       <p:ext uri="{BB962C8B-B14F-4D97-AF65-F5344CB8AC3E}">
@@ -11121,6 +11106,36 @@
           <a:chExt cx="0" cy="0"/>
         </a:xfrm>
       </p:grpSpPr>
+      <p:pic>
+        <p:nvPicPr>
+          <p:cNvPr id="7" name="Picture 6">
+            <a:extLst>
+              <a:ext uri="{FF2B5EF4-FFF2-40B4-BE49-F238E27FC236}">
+                <a16:creationId xmlns:a16="http://schemas.microsoft.com/office/drawing/2014/main" id="{29C2BCC4-5CE5-4CB5-CD8F-8443C90AC083}"/>
+              </a:ext>
+            </a:extLst>
+          </p:cNvPr>
+          <p:cNvPicPr>
+            <a:picLocks noChangeAspect="1"/>
+          </p:cNvPicPr>
+          <p:nvPr/>
+        </p:nvPicPr>
+        <p:blipFill>
+          <a:blip r:embed="rId3"/>
+          <a:stretch>
+            <a:fillRect/>
+          </a:stretch>
+        </p:blipFill>
+        <p:spPr>
+          <a:xfrm>
+            <a:off x="502920" y="1585836"/>
+            <a:ext cx="11025793" cy="5022782"/>
+          </a:xfrm>
+          <a:prstGeom prst="rect">
+            <a:avLst/>
+          </a:prstGeom>
+        </p:spPr>
+      </p:pic>
       <p:sp>
         <p:nvSpPr>
           <p:cNvPr id="2" name="Shape 0">
@@ -11231,51 +11246,6 @@
           </a:p>
         </p:txBody>
       </p:sp>
-      <p:sp>
-        <p:nvSpPr>
-          <p:cNvPr id="11" name="Text 7">
-            <a:extLst>
-              <a:ext uri="{FF2B5EF4-FFF2-40B4-BE49-F238E27FC236}">
-                <a16:creationId xmlns:a16="http://schemas.microsoft.com/office/drawing/2014/main" id="{8D5D9555-57D8-3427-05AC-40D0919C2EA8}"/>
-              </a:ext>
-            </a:extLst>
-          </p:cNvPr>
-          <p:cNvSpPr/>
-          <p:nvPr/>
-        </p:nvSpPr>
-        <p:spPr>
-          <a:xfrm>
-            <a:off x="0" y="6419088"/>
-            <a:ext cx="12191695" cy="320040"/>
-          </a:xfrm>
-          <a:prstGeom prst="rect">
-            <a:avLst/>
-          </a:prstGeom>
-          <a:noFill/>
-          <a:ln/>
-        </p:spPr>
-        <p:txBody>
-          <a:bodyPr wrap="square" lIns="0" tIns="0" rIns="0" bIns="0" rtlCol="0" anchor="ctr"/>
-          <a:lstStyle/>
-          <a:p>
-            <a:pPr marL="0" indent="0" algn="ctr">
-              <a:buNone/>
-            </a:pPr>
-            <a:r>
-              <a:rPr lang="en-US" sz="950" kern="0" spc="200">
-                <a:solidFill>
-                  <a:srgbClr val="8A93A8"/>
-                </a:solidFill>
-                <a:latin typeface="Arial" pitchFamily="34" charset="0"/>
-                <a:ea typeface="Arial" pitchFamily="34" charset="-122"/>
-                <a:cs typeface="Arial" pitchFamily="34" charset="-120"/>
-              </a:rPr>
-              <a:t>D A T A H A C K   S U M M I T   2 0 2 6</a:t>
-            </a:r>
-            <a:endParaRPr lang="en-US" sz="950"/>
-          </a:p>
-        </p:txBody>
-      </p:sp>
       <p:pic>
         <p:nvPicPr>
           <p:cNvPr id="12" name="Picture 11" descr="preencoded.png">
@@ -11291,7 +11261,7 @@
           <p:nvPr/>
         </p:nvPicPr>
         <p:blipFill>
-          <a:blip r:embed="rId3"/>
+          <a:blip r:embed="rId4"/>
           <a:srcRect b="-176"/>
           <a:stretch>
             <a:fillRect/>
@@ -11321,7 +11291,7 @@
         </p:nvSpPr>
         <p:spPr>
           <a:xfrm>
-            <a:off x="512064" y="1417320"/>
+            <a:off x="512064" y="1291599"/>
             <a:ext cx="8686800" cy="411480"/>
           </a:xfrm>
           <a:prstGeom prst="rect">
@@ -11351,41 +11321,6 @@
           </a:p>
         </p:txBody>
       </p:sp>
-      <p:pic>
-        <p:nvPicPr>
-          <p:cNvPr id="6" name="Picture 5">
-            <a:extLst>
-              <a:ext uri="{FF2B5EF4-FFF2-40B4-BE49-F238E27FC236}">
-                <a16:creationId xmlns:a16="http://schemas.microsoft.com/office/drawing/2014/main" id="{0DC85DCE-EF5D-98FD-1C2A-CE6B2E38EB4F}"/>
-              </a:ext>
-            </a:extLst>
-          </p:cNvPr>
-          <p:cNvPicPr>
-            <a:picLocks noChangeAspect="1"/>
-          </p:cNvPicPr>
-          <p:nvPr/>
-        </p:nvPicPr>
-        <p:blipFill>
-          <a:blip r:embed="rId4"/>
-          <a:stretch>
-            <a:fillRect/>
-          </a:stretch>
-        </p:blipFill>
-        <p:spPr>
-          <a:xfrm>
-            <a:off x="646826" y="1743791"/>
-            <a:ext cx="10227787" cy="4760307"/>
-          </a:xfrm>
-          <a:prstGeom prst="rect">
-            <a:avLst/>
-          </a:prstGeom>
-          <a:ln>
-            <a:solidFill>
-              <a:schemeClr val="bg1"/>
-            </a:solidFill>
-          </a:ln>
-        </p:spPr>
-      </p:pic>
     </p:spTree>
     <p:extLst>
       <p:ext uri="{BB962C8B-B14F-4D97-AF65-F5344CB8AC3E}">
@@ -12158,6 +12093,36 @@
           <a:chExt cx="0" cy="0"/>
         </a:xfrm>
       </p:grpSpPr>
+      <p:pic>
+        <p:nvPicPr>
+          <p:cNvPr id="7" name="Picture 6">
+            <a:extLst>
+              <a:ext uri="{FF2B5EF4-FFF2-40B4-BE49-F238E27FC236}">
+                <a16:creationId xmlns:a16="http://schemas.microsoft.com/office/drawing/2014/main" id="{A41AE82F-AB7A-67D1-7838-944D995ADE3B}"/>
+              </a:ext>
+            </a:extLst>
+          </p:cNvPr>
+          <p:cNvPicPr>
+            <a:picLocks noChangeAspect="1"/>
+          </p:cNvPicPr>
+          <p:nvPr/>
+        </p:nvPicPr>
+        <p:blipFill>
+          <a:blip r:embed="rId3"/>
+          <a:stretch>
+            <a:fillRect/>
+          </a:stretch>
+        </p:blipFill>
+        <p:spPr>
+          <a:xfrm>
+            <a:off x="544068" y="1459262"/>
+            <a:ext cx="11183112" cy="5245429"/>
+          </a:xfrm>
+          <a:prstGeom prst="rect">
+            <a:avLst/>
+          </a:prstGeom>
+        </p:spPr>
+      </p:pic>
       <p:sp>
         <p:nvSpPr>
           <p:cNvPr id="2" name="Shape 0">
@@ -12268,51 +12233,6 @@
           </a:p>
         </p:txBody>
       </p:sp>
-      <p:sp>
-        <p:nvSpPr>
-          <p:cNvPr id="11" name="Text 7">
-            <a:extLst>
-              <a:ext uri="{FF2B5EF4-FFF2-40B4-BE49-F238E27FC236}">
-                <a16:creationId xmlns:a16="http://schemas.microsoft.com/office/drawing/2014/main" id="{FF34BB30-93DC-9D43-9063-EF6ED101E348}"/>
-              </a:ext>
-            </a:extLst>
-          </p:cNvPr>
-          <p:cNvSpPr/>
-          <p:nvPr/>
-        </p:nvSpPr>
-        <p:spPr>
-          <a:xfrm>
-            <a:off x="0" y="6419088"/>
-            <a:ext cx="12191695" cy="320040"/>
-          </a:xfrm>
-          <a:prstGeom prst="rect">
-            <a:avLst/>
-          </a:prstGeom>
-          <a:noFill/>
-          <a:ln/>
-        </p:spPr>
-        <p:txBody>
-          <a:bodyPr wrap="square" lIns="0" tIns="0" rIns="0" bIns="0" rtlCol="0" anchor="ctr"/>
-          <a:lstStyle/>
-          <a:p>
-            <a:pPr marL="0" indent="0" algn="ctr">
-              <a:buNone/>
-            </a:pPr>
-            <a:r>
-              <a:rPr lang="en-US" sz="950" kern="0" spc="200">
-                <a:solidFill>
-                  <a:srgbClr val="8A93A8"/>
-                </a:solidFill>
-                <a:latin typeface="Arial" pitchFamily="34" charset="0"/>
-                <a:ea typeface="Arial" pitchFamily="34" charset="-122"/>
-                <a:cs typeface="Arial" pitchFamily="34" charset="-120"/>
-              </a:rPr>
-              <a:t>D A T A H A C K   S U M M I T   2 0 2 6</a:t>
-            </a:r>
-            <a:endParaRPr lang="en-US" sz="950"/>
-          </a:p>
-        </p:txBody>
-      </p:sp>
       <p:pic>
         <p:nvPicPr>
           <p:cNvPr id="12" name="Picture 11" descr="preencoded.png">
@@ -12328,7 +12248,7 @@
           <p:nvPr/>
         </p:nvPicPr>
         <p:blipFill>
-          <a:blip r:embed="rId3"/>
+          <a:blip r:embed="rId4"/>
           <a:srcRect b="-176"/>
           <a:stretch>
             <a:fillRect/>
@@ -12342,41 +12262,6 @@
           <a:prstGeom prst="rect">
             <a:avLst/>
           </a:prstGeom>
-        </p:spPr>
-      </p:pic>
-      <p:pic>
-        <p:nvPicPr>
-          <p:cNvPr id="5" name="Picture 4">
-            <a:extLst>
-              <a:ext uri="{FF2B5EF4-FFF2-40B4-BE49-F238E27FC236}">
-                <a16:creationId xmlns:a16="http://schemas.microsoft.com/office/drawing/2014/main" id="{0A3373B3-A5B0-060F-CCCE-BE9470380F6C}"/>
-              </a:ext>
-            </a:extLst>
-          </p:cNvPr>
-          <p:cNvPicPr>
-            <a:picLocks noChangeAspect="1"/>
-          </p:cNvPicPr>
-          <p:nvPr/>
-        </p:nvPicPr>
-        <p:blipFill>
-          <a:blip r:embed="rId4"/>
-          <a:stretch>
-            <a:fillRect/>
-          </a:stretch>
-        </p:blipFill>
-        <p:spPr>
-          <a:xfrm>
-            <a:off x="841335" y="1495672"/>
-            <a:ext cx="9838769" cy="4786256"/>
-          </a:xfrm>
-          <a:prstGeom prst="rect">
-            <a:avLst/>
-          </a:prstGeom>
-          <a:ln>
-            <a:solidFill>
-              <a:schemeClr val="bg1"/>
-            </a:solidFill>
-          </a:ln>
         </p:spPr>
       </p:pic>
     </p:spTree>
@@ -12425,10 +12310,10 @@
       </p:grpSpPr>
       <p:pic>
         <p:nvPicPr>
-          <p:cNvPr id="14" name="Picture 13">
-            <a:extLst>
-              <a:ext uri="{FF2B5EF4-FFF2-40B4-BE49-F238E27FC236}">
-                <a16:creationId xmlns:a16="http://schemas.microsoft.com/office/drawing/2014/main" id="{A6F2260B-15AF-1E7D-333A-C2251F1FCCD4}"/>
+          <p:cNvPr id="6" name="Picture 5">
+            <a:extLst>
+              <a:ext uri="{FF2B5EF4-FFF2-40B4-BE49-F238E27FC236}">
+                <a16:creationId xmlns:a16="http://schemas.microsoft.com/office/drawing/2014/main" id="{DE452BE9-7398-900F-7715-117FDB28A3BA}"/>
               </a:ext>
             </a:extLst>
           </p:cNvPr>
@@ -12445,19 +12330,12 @@
         </p:blipFill>
         <p:spPr>
           <a:xfrm>
-            <a:off x="4665974" y="2526211"/>
-            <a:ext cx="6738453" cy="3296888"/>
-          </a:xfrm>
-          <a:prstGeom prst="rect">
-            <a:avLst/>
-          </a:prstGeom>
-          <a:ln>
-            <a:solidFill>
-              <a:schemeClr val="bg1">
-                <a:lumMod val="85000"/>
-              </a:schemeClr>
-            </a:solidFill>
-          </a:ln>
+            <a:off x="3433598" y="1383178"/>
+            <a:ext cx="8588684" cy="3951483"/>
+          </a:xfrm>
+          <a:prstGeom prst="rect">
+            <a:avLst/>
+          </a:prstGeom>
         </p:spPr>
       </p:pic>
       <p:sp>
@@ -12584,8 +12462,8 @@
         </p:nvSpPr>
         <p:spPr>
           <a:xfrm>
-            <a:off x="585216" y="1852146"/>
-            <a:ext cx="4378037" cy="667512"/>
+            <a:off x="585216" y="2503653"/>
+            <a:ext cx="3134729" cy="667512"/>
           </a:xfrm>
           <a:prstGeom prst="rect">
             <a:avLst/>
@@ -12631,7 +12509,7 @@
         </p:nvSpPr>
         <p:spPr>
           <a:xfrm>
-            <a:off x="929175" y="2521505"/>
+            <a:off x="929175" y="3173012"/>
             <a:ext cx="4378036" cy="265176"/>
           </a:xfrm>
           <a:prstGeom prst="rect">
@@ -12678,7 +12556,7 @@
         </p:nvSpPr>
         <p:spPr>
           <a:xfrm>
-            <a:off x="596646" y="2874727"/>
+            <a:off x="596646" y="3526234"/>
             <a:ext cx="146304" cy="146304"/>
           </a:xfrm>
           <a:prstGeom prst="ellipse">
@@ -12711,7 +12589,7 @@
         </p:nvSpPr>
         <p:spPr>
           <a:xfrm>
-            <a:off x="929175" y="2828199"/>
+            <a:off x="929175" y="3479706"/>
             <a:ext cx="7406640" cy="265176"/>
           </a:xfrm>
           <a:prstGeom prst="rect">
@@ -12834,7 +12712,7 @@
         </p:nvSpPr>
         <p:spPr>
           <a:xfrm>
-            <a:off x="596646" y="2568033"/>
+            <a:off x="596646" y="3219540"/>
             <a:ext cx="146304" cy="146304"/>
           </a:xfrm>
           <a:prstGeom prst="ellipse">
@@ -12867,7 +12745,7 @@
         </p:nvSpPr>
         <p:spPr>
           <a:xfrm>
-            <a:off x="929175" y="3134893"/>
+            <a:off x="929175" y="3786400"/>
             <a:ext cx="4378036" cy="265176"/>
           </a:xfrm>
           <a:prstGeom prst="rect">
@@ -12914,7 +12792,7 @@
         </p:nvSpPr>
         <p:spPr>
           <a:xfrm>
-            <a:off x="596646" y="3488115"/>
+            <a:off x="596646" y="4139622"/>
             <a:ext cx="146304" cy="146304"/>
           </a:xfrm>
           <a:prstGeom prst="ellipse">
@@ -12947,7 +12825,7 @@
         </p:nvSpPr>
         <p:spPr>
           <a:xfrm>
-            <a:off x="929175" y="3441587"/>
+            <a:off x="929175" y="4093094"/>
             <a:ext cx="7406640" cy="265176"/>
           </a:xfrm>
           <a:prstGeom prst="rect">
@@ -12994,7 +12872,7 @@
         </p:nvSpPr>
         <p:spPr>
           <a:xfrm>
-            <a:off x="596646" y="3181421"/>
+            <a:off x="596646" y="3832928"/>
             <a:ext cx="146304" cy="146304"/>
           </a:xfrm>
           <a:prstGeom prst="ellipse">
@@ -13027,7 +12905,7 @@
         </p:nvSpPr>
         <p:spPr>
           <a:xfrm>
-            <a:off x="929175" y="3748281"/>
+            <a:off x="929175" y="4399788"/>
             <a:ext cx="4378036" cy="265176"/>
           </a:xfrm>
           <a:prstGeom prst="rect">
@@ -13074,7 +12952,7 @@
         </p:nvSpPr>
         <p:spPr>
           <a:xfrm>
-            <a:off x="596646" y="4101503"/>
+            <a:off x="596646" y="4753010"/>
             <a:ext cx="146304" cy="146304"/>
           </a:xfrm>
           <a:prstGeom prst="ellipse">
@@ -13107,7 +12985,7 @@
         </p:nvSpPr>
         <p:spPr>
           <a:xfrm>
-            <a:off x="929175" y="4054975"/>
+            <a:off x="929175" y="4706482"/>
             <a:ext cx="7406640" cy="265176"/>
           </a:xfrm>
           <a:prstGeom prst="rect">
@@ -13154,7 +13032,7 @@
         </p:nvSpPr>
         <p:spPr>
           <a:xfrm>
-            <a:off x="596646" y="3794809"/>
+            <a:off x="596646" y="4446316"/>
             <a:ext cx="146304" cy="146304"/>
           </a:xfrm>
           <a:prstGeom prst="ellipse">
@@ -13187,7 +13065,7 @@
         </p:nvSpPr>
         <p:spPr>
           <a:xfrm>
-            <a:off x="929175" y="4361669"/>
+            <a:off x="929175" y="5013176"/>
             <a:ext cx="4378036" cy="265176"/>
           </a:xfrm>
           <a:prstGeom prst="rect">
@@ -13234,7 +13112,7 @@
         </p:nvSpPr>
         <p:spPr>
           <a:xfrm>
-            <a:off x="596646" y="4408195"/>
+            <a:off x="596646" y="5059702"/>
             <a:ext cx="146304" cy="146304"/>
           </a:xfrm>
           <a:prstGeom prst="ellipse">
@@ -13297,6 +13175,41 @@
           <a:chExt cx="0" cy="0"/>
         </a:xfrm>
       </p:grpSpPr>
+      <p:pic>
+        <p:nvPicPr>
+          <p:cNvPr id="5" name="Picture 4">
+            <a:extLst>
+              <a:ext uri="{FF2B5EF4-FFF2-40B4-BE49-F238E27FC236}">
+                <a16:creationId xmlns:a16="http://schemas.microsoft.com/office/drawing/2014/main" id="{5092CD10-02FB-33BC-1A14-B4D82E412694}"/>
+              </a:ext>
+            </a:extLst>
+          </p:cNvPr>
+          <p:cNvPicPr>
+            <a:picLocks noChangeAspect="1"/>
+          </p:cNvPicPr>
+          <p:nvPr/>
+        </p:nvPicPr>
+        <p:blipFill>
+          <a:blip r:embed="rId3"/>
+          <a:stretch>
+            <a:fillRect/>
+          </a:stretch>
+        </p:blipFill>
+        <p:spPr>
+          <a:xfrm>
+            <a:off x="731520" y="1351451"/>
+            <a:ext cx="10693211" cy="5231813"/>
+          </a:xfrm>
+          <a:prstGeom prst="rect">
+            <a:avLst/>
+          </a:prstGeom>
+          <a:ln>
+            <a:solidFill>
+              <a:schemeClr val="bg1"/>
+            </a:solidFill>
+          </a:ln>
+        </p:spPr>
+      </p:pic>
       <p:sp>
         <p:nvSpPr>
           <p:cNvPr id="2" name="Shape 0">
@@ -13467,7 +13380,7 @@
           <p:nvPr/>
         </p:nvPicPr>
         <p:blipFill>
-          <a:blip r:embed="rId3"/>
+          <a:blip r:embed="rId4"/>
           <a:srcRect b="-176"/>
           <a:stretch>
             <a:fillRect/>
@@ -13481,41 +13394,6 @@
           <a:prstGeom prst="rect">
             <a:avLst/>
           </a:prstGeom>
-        </p:spPr>
-      </p:pic>
-      <p:pic>
-        <p:nvPicPr>
-          <p:cNvPr id="5" name="Picture 4">
-            <a:extLst>
-              <a:ext uri="{FF2B5EF4-FFF2-40B4-BE49-F238E27FC236}">
-                <a16:creationId xmlns:a16="http://schemas.microsoft.com/office/drawing/2014/main" id="{5092CD10-02FB-33BC-1A14-B4D82E412694}"/>
-              </a:ext>
-            </a:extLst>
-          </p:cNvPr>
-          <p:cNvPicPr>
-            <a:picLocks noChangeAspect="1"/>
-          </p:cNvPicPr>
-          <p:nvPr/>
-        </p:nvPicPr>
-        <p:blipFill>
-          <a:blip r:embed="rId4"/>
-          <a:stretch>
-            <a:fillRect/>
-          </a:stretch>
-        </p:blipFill>
-        <p:spPr>
-          <a:xfrm>
-            <a:off x="999751" y="1516209"/>
-            <a:ext cx="10192497" cy="4986831"/>
-          </a:xfrm>
-          <a:prstGeom prst="rect">
-            <a:avLst/>
-          </a:prstGeom>
-          <a:ln>
-            <a:solidFill>
-              <a:schemeClr val="bg1"/>
-            </a:solidFill>
-          </a:ln>
         </p:spPr>
       </p:pic>
     </p:spTree>
@@ -14617,8 +14495,8 @@
         </p:blipFill>
         <p:spPr>
           <a:xfrm>
-            <a:off x="4733032" y="1937802"/>
-            <a:ext cx="6912082" cy="3940958"/>
+            <a:off x="3628022" y="1516193"/>
+            <a:ext cx="8017092" cy="4570985"/>
           </a:xfrm>
           <a:prstGeom prst="rect">
             <a:avLst/>
@@ -15683,167 +15561,12 @@
           <a:chExt cx="0" cy="0"/>
         </a:xfrm>
       </p:grpSpPr>
-      <p:sp>
-        <p:nvSpPr>
-          <p:cNvPr id="2" name="Shape 0">
-            <a:extLst>
-              <a:ext uri="{FF2B5EF4-FFF2-40B4-BE49-F238E27FC236}">
-                <a16:creationId xmlns:a16="http://schemas.microsoft.com/office/drawing/2014/main" id="{FA9B82A1-D7CA-8BEB-80C8-23D4CFBE3D8C}"/>
-              </a:ext>
-            </a:extLst>
-          </p:cNvPr>
-          <p:cNvSpPr/>
-          <p:nvPr/>
-        </p:nvSpPr>
-        <p:spPr>
-          <a:xfrm>
-            <a:off x="502920" y="548640"/>
-            <a:ext cx="82296" cy="603504"/>
-          </a:xfrm>
-          <a:prstGeom prst="rect">
-            <a:avLst/>
-          </a:prstGeom>
-          <a:solidFill>
-            <a:srgbClr val="FE7202"/>
-          </a:solidFill>
-          <a:ln/>
-        </p:spPr>
-        <p:txBody>
-          <a:bodyPr/>
-          <a:lstStyle/>
-          <a:p>
-            <a:endParaRPr lang="en-US"/>
-          </a:p>
-        </p:txBody>
-      </p:sp>
-      <p:sp>
-        <p:nvSpPr>
-          <p:cNvPr id="3" name="Text 1">
-            <a:extLst>
-              <a:ext uri="{FF2B5EF4-FFF2-40B4-BE49-F238E27FC236}">
-                <a16:creationId xmlns:a16="http://schemas.microsoft.com/office/drawing/2014/main" id="{FB3F4146-1C2F-C10A-BA11-AC25936B64E6}"/>
-              </a:ext>
-            </a:extLst>
-          </p:cNvPr>
-          <p:cNvSpPr/>
-          <p:nvPr/>
-        </p:nvSpPr>
-        <p:spPr>
-          <a:xfrm>
-            <a:off x="731520" y="502920"/>
-            <a:ext cx="10058400" cy="713232"/>
-          </a:xfrm>
-          <a:prstGeom prst="rect">
-            <a:avLst/>
-          </a:prstGeom>
-          <a:noFill/>
-          <a:ln/>
-        </p:spPr>
-        <p:txBody>
-          <a:bodyPr wrap="square" lIns="0" tIns="0" rIns="0" bIns="0" rtlCol="0" anchor="ctr"/>
-          <a:lstStyle/>
-          <a:p>
-            <a:pPr marL="0" indent="0">
-              <a:buNone/>
-            </a:pPr>
-            <a:r>
-              <a:rPr lang="en-US" sz="2900" b="1" dirty="0">
-                <a:solidFill>
-                  <a:srgbClr val="0F2247"/>
-                </a:solidFill>
-                <a:latin typeface="Arial" pitchFamily="34" charset="0"/>
-                <a:ea typeface="Arial" pitchFamily="34" charset="-122"/>
-                <a:cs typeface="Arial" pitchFamily="34" charset="-120"/>
-              </a:rPr>
-              <a:t>Layer 4: Context Layer Trace</a:t>
-            </a:r>
-          </a:p>
-        </p:txBody>
-      </p:sp>
-      <p:sp>
-        <p:nvSpPr>
-          <p:cNvPr id="4" name="Shape 2">
-            <a:extLst>
-              <a:ext uri="{FF2B5EF4-FFF2-40B4-BE49-F238E27FC236}">
-                <a16:creationId xmlns:a16="http://schemas.microsoft.com/office/drawing/2014/main" id="{AC673C2A-3A66-D888-7383-51050E281279}"/>
-              </a:ext>
-            </a:extLst>
-          </p:cNvPr>
-          <p:cNvSpPr/>
-          <p:nvPr/>
-        </p:nvSpPr>
-        <p:spPr>
-          <a:xfrm>
-            <a:off x="502920" y="1325880"/>
-            <a:ext cx="11183112" cy="27432"/>
-          </a:xfrm>
-          <a:prstGeom prst="rect">
-            <a:avLst/>
-          </a:prstGeom>
-          <a:solidFill>
-            <a:srgbClr val="FE7202"/>
-          </a:solidFill>
-          <a:ln/>
-        </p:spPr>
-        <p:txBody>
-          <a:bodyPr/>
-          <a:lstStyle/>
-          <a:p>
-            <a:endParaRPr lang="en-US"/>
-          </a:p>
-        </p:txBody>
-      </p:sp>
-      <p:sp>
-        <p:nvSpPr>
-          <p:cNvPr id="21" name="Text 18">
-            <a:extLst>
-              <a:ext uri="{FF2B5EF4-FFF2-40B4-BE49-F238E27FC236}">
-                <a16:creationId xmlns:a16="http://schemas.microsoft.com/office/drawing/2014/main" id="{D198F756-AF41-B2C7-70EB-6BF28528ED7A}"/>
-              </a:ext>
-            </a:extLst>
-          </p:cNvPr>
-          <p:cNvSpPr/>
-          <p:nvPr/>
-        </p:nvSpPr>
-        <p:spPr>
-          <a:xfrm>
-            <a:off x="305" y="6428694"/>
-            <a:ext cx="12191695" cy="320040"/>
-          </a:xfrm>
-          <a:prstGeom prst="rect">
-            <a:avLst/>
-          </a:prstGeom>
-          <a:noFill/>
-          <a:ln/>
-        </p:spPr>
-        <p:txBody>
-          <a:bodyPr wrap="square" lIns="0" tIns="0" rIns="0" bIns="0" rtlCol="0" anchor="ctr"/>
-          <a:lstStyle/>
-          <a:p>
-            <a:pPr marL="0" indent="0" algn="ctr">
-              <a:buNone/>
-            </a:pPr>
-            <a:r>
-              <a:rPr lang="en-US" sz="950" kern="0" spc="200">
-                <a:solidFill>
-                  <a:srgbClr val="8A93A8"/>
-                </a:solidFill>
-                <a:latin typeface="Arial" pitchFamily="34" charset="0"/>
-                <a:ea typeface="Arial" pitchFamily="34" charset="-122"/>
-                <a:cs typeface="Arial" pitchFamily="34" charset="-120"/>
-              </a:rPr>
-              <a:t>D A T A H A C K   S U M M I T   2 0 2 6</a:t>
-            </a:r>
-            <a:endParaRPr lang="en-US" sz="950"/>
-          </a:p>
-        </p:txBody>
-      </p:sp>
       <p:pic>
         <p:nvPicPr>
-          <p:cNvPr id="23" name="Picture 22" descr="preencoded.png">
-            <a:extLst>
-              <a:ext uri="{FF2B5EF4-FFF2-40B4-BE49-F238E27FC236}">
-                <a16:creationId xmlns:a16="http://schemas.microsoft.com/office/drawing/2014/main" id="{D662942A-8350-098E-14CC-4BC368F20894}"/>
+          <p:cNvPr id="7" name="Picture 6">
+            <a:extLst>
+              <a:ext uri="{FF2B5EF4-FFF2-40B4-BE49-F238E27FC236}">
+                <a16:creationId xmlns:a16="http://schemas.microsoft.com/office/drawing/2014/main" id="{6CC93380-10DD-6086-ACF6-9B01738E0E2B}"/>
               </a:ext>
             </a:extLst>
           </p:cNvPr>
@@ -15854,89 +15577,14 @@
         </p:nvPicPr>
         <p:blipFill>
           <a:blip r:embed="rId3"/>
-          <a:srcRect b="-176"/>
           <a:stretch>
             <a:fillRect/>
           </a:stretch>
         </p:blipFill>
         <p:spPr>
           <a:xfrm>
-            <a:off x="10792419" y="367621"/>
-            <a:ext cx="852695" cy="852309"/>
-          </a:xfrm>
-          <a:prstGeom prst="rect">
-            <a:avLst/>
-          </a:prstGeom>
-        </p:spPr>
-      </p:pic>
-      <p:sp>
-        <p:nvSpPr>
-          <p:cNvPr id="6" name="Text 3">
-            <a:extLst>
-              <a:ext uri="{FF2B5EF4-FFF2-40B4-BE49-F238E27FC236}">
-                <a16:creationId xmlns:a16="http://schemas.microsoft.com/office/drawing/2014/main" id="{3285D5A8-ACAA-0F2C-6FFA-28EAC44DD4DF}"/>
-              </a:ext>
-            </a:extLst>
-          </p:cNvPr>
-          <p:cNvSpPr/>
-          <p:nvPr/>
-        </p:nvSpPr>
-        <p:spPr>
-          <a:xfrm>
-            <a:off x="512064" y="1380376"/>
-            <a:ext cx="8686800" cy="411480"/>
-          </a:xfrm>
-          <a:prstGeom prst="rect">
-            <a:avLst/>
-          </a:prstGeom>
-          <a:noFill/>
-          <a:ln/>
-        </p:spPr>
-        <p:txBody>
-          <a:bodyPr wrap="square" lIns="0" tIns="0" rIns="0" bIns="0" rtlCol="0" anchor="ctr"/>
-          <a:lstStyle/>
-          <a:p>
-            <a:pPr marL="0" indent="0">
-              <a:buNone/>
-            </a:pPr>
-            <a:r>
-              <a:rPr lang="en-US" sz="1350" i="1" dirty="0">
-                <a:solidFill>
-                  <a:srgbClr val="8A93A8"/>
-                </a:solidFill>
-                <a:latin typeface="Calibri" pitchFamily="34" charset="0"/>
-                <a:ea typeface="Calibri" pitchFamily="34" charset="-122"/>
-                <a:cs typeface="Calibri" pitchFamily="34" charset="-120"/>
-              </a:rPr>
-              <a:t>MCP Gateways</a:t>
-            </a:r>
-          </a:p>
-        </p:txBody>
-      </p:sp>
-      <p:pic>
-        <p:nvPicPr>
-          <p:cNvPr id="7" name="Picture 6">
-            <a:extLst>
-              <a:ext uri="{FF2B5EF4-FFF2-40B4-BE49-F238E27FC236}">
-                <a16:creationId xmlns:a16="http://schemas.microsoft.com/office/drawing/2014/main" id="{6CC93380-10DD-6086-ACF6-9B01738E0E2B}"/>
-              </a:ext>
-            </a:extLst>
-          </p:cNvPr>
-          <p:cNvPicPr>
-            <a:picLocks noChangeAspect="1"/>
-          </p:cNvPicPr>
-          <p:nvPr/>
-        </p:nvPicPr>
-        <p:blipFill>
-          <a:blip r:embed="rId4"/>
-          <a:stretch>
-            <a:fillRect/>
-          </a:stretch>
-        </p:blipFill>
-        <p:spPr>
-          <a:xfrm>
-            <a:off x="1328945" y="1818920"/>
-            <a:ext cx="9531062" cy="4571459"/>
+            <a:off x="1201566" y="1735043"/>
+            <a:ext cx="9785820" cy="4693651"/>
           </a:xfrm>
           <a:prstGeom prst="rect">
             <a:avLst/>
@@ -15950,6 +15598,236 @@
           </a:ln>
         </p:spPr>
       </p:pic>
+      <p:sp>
+        <p:nvSpPr>
+          <p:cNvPr id="2" name="Shape 0">
+            <a:extLst>
+              <a:ext uri="{FF2B5EF4-FFF2-40B4-BE49-F238E27FC236}">
+                <a16:creationId xmlns:a16="http://schemas.microsoft.com/office/drawing/2014/main" id="{FA9B82A1-D7CA-8BEB-80C8-23D4CFBE3D8C}"/>
+              </a:ext>
+            </a:extLst>
+          </p:cNvPr>
+          <p:cNvSpPr/>
+          <p:nvPr/>
+        </p:nvSpPr>
+        <p:spPr>
+          <a:xfrm>
+            <a:off x="502920" y="548640"/>
+            <a:ext cx="82296" cy="603504"/>
+          </a:xfrm>
+          <a:prstGeom prst="rect">
+            <a:avLst/>
+          </a:prstGeom>
+          <a:solidFill>
+            <a:srgbClr val="FE7202"/>
+          </a:solidFill>
+          <a:ln/>
+        </p:spPr>
+        <p:txBody>
+          <a:bodyPr/>
+          <a:lstStyle/>
+          <a:p>
+            <a:endParaRPr lang="en-US"/>
+          </a:p>
+        </p:txBody>
+      </p:sp>
+      <p:sp>
+        <p:nvSpPr>
+          <p:cNvPr id="3" name="Text 1">
+            <a:extLst>
+              <a:ext uri="{FF2B5EF4-FFF2-40B4-BE49-F238E27FC236}">
+                <a16:creationId xmlns:a16="http://schemas.microsoft.com/office/drawing/2014/main" id="{FB3F4146-1C2F-C10A-BA11-AC25936B64E6}"/>
+              </a:ext>
+            </a:extLst>
+          </p:cNvPr>
+          <p:cNvSpPr/>
+          <p:nvPr/>
+        </p:nvSpPr>
+        <p:spPr>
+          <a:xfrm>
+            <a:off x="731520" y="502920"/>
+            <a:ext cx="10058400" cy="713232"/>
+          </a:xfrm>
+          <a:prstGeom prst="rect">
+            <a:avLst/>
+          </a:prstGeom>
+          <a:noFill/>
+          <a:ln/>
+        </p:spPr>
+        <p:txBody>
+          <a:bodyPr wrap="square" lIns="0" tIns="0" rIns="0" bIns="0" rtlCol="0" anchor="ctr"/>
+          <a:lstStyle/>
+          <a:p>
+            <a:pPr marL="0" indent="0">
+              <a:buNone/>
+            </a:pPr>
+            <a:r>
+              <a:rPr lang="en-US" sz="2900" b="1" dirty="0">
+                <a:solidFill>
+                  <a:srgbClr val="0F2247"/>
+                </a:solidFill>
+                <a:latin typeface="Arial" pitchFamily="34" charset="0"/>
+                <a:ea typeface="Arial" pitchFamily="34" charset="-122"/>
+                <a:cs typeface="Arial" pitchFamily="34" charset="-120"/>
+              </a:rPr>
+              <a:t>Layer 4: Context Layer Trace</a:t>
+            </a:r>
+          </a:p>
+        </p:txBody>
+      </p:sp>
+      <p:sp>
+        <p:nvSpPr>
+          <p:cNvPr id="4" name="Shape 2">
+            <a:extLst>
+              <a:ext uri="{FF2B5EF4-FFF2-40B4-BE49-F238E27FC236}">
+                <a16:creationId xmlns:a16="http://schemas.microsoft.com/office/drawing/2014/main" id="{AC673C2A-3A66-D888-7383-51050E281279}"/>
+              </a:ext>
+            </a:extLst>
+          </p:cNvPr>
+          <p:cNvSpPr/>
+          <p:nvPr/>
+        </p:nvSpPr>
+        <p:spPr>
+          <a:xfrm>
+            <a:off x="502920" y="1325880"/>
+            <a:ext cx="11183112" cy="27432"/>
+          </a:xfrm>
+          <a:prstGeom prst="rect">
+            <a:avLst/>
+          </a:prstGeom>
+          <a:solidFill>
+            <a:srgbClr val="FE7202"/>
+          </a:solidFill>
+          <a:ln/>
+        </p:spPr>
+        <p:txBody>
+          <a:bodyPr/>
+          <a:lstStyle/>
+          <a:p>
+            <a:endParaRPr lang="en-US"/>
+          </a:p>
+        </p:txBody>
+      </p:sp>
+      <p:sp>
+        <p:nvSpPr>
+          <p:cNvPr id="21" name="Text 18">
+            <a:extLst>
+              <a:ext uri="{FF2B5EF4-FFF2-40B4-BE49-F238E27FC236}">
+                <a16:creationId xmlns:a16="http://schemas.microsoft.com/office/drawing/2014/main" id="{D198F756-AF41-B2C7-70EB-6BF28528ED7A}"/>
+              </a:ext>
+            </a:extLst>
+          </p:cNvPr>
+          <p:cNvSpPr/>
+          <p:nvPr/>
+        </p:nvSpPr>
+        <p:spPr>
+          <a:xfrm>
+            <a:off x="305" y="6428694"/>
+            <a:ext cx="12191695" cy="320040"/>
+          </a:xfrm>
+          <a:prstGeom prst="rect">
+            <a:avLst/>
+          </a:prstGeom>
+          <a:noFill/>
+          <a:ln/>
+        </p:spPr>
+        <p:txBody>
+          <a:bodyPr wrap="square" lIns="0" tIns="0" rIns="0" bIns="0" rtlCol="0" anchor="ctr"/>
+          <a:lstStyle/>
+          <a:p>
+            <a:pPr marL="0" indent="0" algn="ctr">
+              <a:buNone/>
+            </a:pPr>
+            <a:r>
+              <a:rPr lang="en-US" sz="950" kern="0" spc="200">
+                <a:solidFill>
+                  <a:srgbClr val="8A93A8"/>
+                </a:solidFill>
+                <a:latin typeface="Arial" pitchFamily="34" charset="0"/>
+                <a:ea typeface="Arial" pitchFamily="34" charset="-122"/>
+                <a:cs typeface="Arial" pitchFamily="34" charset="-120"/>
+              </a:rPr>
+              <a:t>D A T A H A C K   S U M M I T   2 0 2 6</a:t>
+            </a:r>
+            <a:endParaRPr lang="en-US" sz="950"/>
+          </a:p>
+        </p:txBody>
+      </p:sp>
+      <p:pic>
+        <p:nvPicPr>
+          <p:cNvPr id="23" name="Picture 22" descr="preencoded.png">
+            <a:extLst>
+              <a:ext uri="{FF2B5EF4-FFF2-40B4-BE49-F238E27FC236}">
+                <a16:creationId xmlns:a16="http://schemas.microsoft.com/office/drawing/2014/main" id="{D662942A-8350-098E-14CC-4BC368F20894}"/>
+              </a:ext>
+            </a:extLst>
+          </p:cNvPr>
+          <p:cNvPicPr>
+            <a:picLocks noChangeAspect="1"/>
+          </p:cNvPicPr>
+          <p:nvPr/>
+        </p:nvPicPr>
+        <p:blipFill>
+          <a:blip r:embed="rId4"/>
+          <a:srcRect b="-176"/>
+          <a:stretch>
+            <a:fillRect/>
+          </a:stretch>
+        </p:blipFill>
+        <p:spPr>
+          <a:xfrm>
+            <a:off x="10792419" y="367621"/>
+            <a:ext cx="852695" cy="852309"/>
+          </a:xfrm>
+          <a:prstGeom prst="rect">
+            <a:avLst/>
+          </a:prstGeom>
+        </p:spPr>
+      </p:pic>
+      <p:sp>
+        <p:nvSpPr>
+          <p:cNvPr id="6" name="Text 3">
+            <a:extLst>
+              <a:ext uri="{FF2B5EF4-FFF2-40B4-BE49-F238E27FC236}">
+                <a16:creationId xmlns:a16="http://schemas.microsoft.com/office/drawing/2014/main" id="{3285D5A8-ACAA-0F2C-6FFA-28EAC44DD4DF}"/>
+              </a:ext>
+            </a:extLst>
+          </p:cNvPr>
+          <p:cNvSpPr/>
+          <p:nvPr/>
+        </p:nvSpPr>
+        <p:spPr>
+          <a:xfrm>
+            <a:off x="512064" y="1380376"/>
+            <a:ext cx="8686800" cy="411480"/>
+          </a:xfrm>
+          <a:prstGeom prst="rect">
+            <a:avLst/>
+          </a:prstGeom>
+          <a:noFill/>
+          <a:ln/>
+        </p:spPr>
+        <p:txBody>
+          <a:bodyPr wrap="square" lIns="0" tIns="0" rIns="0" bIns="0" rtlCol="0" anchor="ctr"/>
+          <a:lstStyle/>
+          <a:p>
+            <a:pPr marL="0" indent="0">
+              <a:buNone/>
+            </a:pPr>
+            <a:r>
+              <a:rPr lang="en-US" sz="1350" i="1" dirty="0">
+                <a:solidFill>
+                  <a:srgbClr val="8A93A8"/>
+                </a:solidFill>
+                <a:latin typeface="Calibri" pitchFamily="34" charset="0"/>
+                <a:ea typeface="Calibri" pitchFamily="34" charset="-122"/>
+                <a:cs typeface="Calibri" pitchFamily="34" charset="-120"/>
+              </a:rPr>
+              <a:t>MCP Gateways</a:t>
+            </a:r>
+          </a:p>
+        </p:txBody>
+      </p:sp>
     </p:spTree>
     <p:extLst>
       <p:ext uri="{BB962C8B-B14F-4D97-AF65-F5344CB8AC3E}">
@@ -15994,6 +15872,36 @@
           <a:chExt cx="0" cy="0"/>
         </a:xfrm>
       </p:grpSpPr>
+      <p:pic>
+        <p:nvPicPr>
+          <p:cNvPr id="6" name="Picture 5">
+            <a:extLst>
+              <a:ext uri="{FF2B5EF4-FFF2-40B4-BE49-F238E27FC236}">
+                <a16:creationId xmlns:a16="http://schemas.microsoft.com/office/drawing/2014/main" id="{0AD5D684-2EF9-847D-F618-E91B2F6639CA}"/>
+              </a:ext>
+            </a:extLst>
+          </p:cNvPr>
+          <p:cNvPicPr>
+            <a:picLocks noChangeAspect="1"/>
+          </p:cNvPicPr>
+          <p:nvPr/>
+        </p:nvPicPr>
+        <p:blipFill>
+          <a:blip r:embed="rId3"/>
+          <a:stretch>
+            <a:fillRect/>
+          </a:stretch>
+        </p:blipFill>
+        <p:spPr>
+          <a:xfrm>
+            <a:off x="661160" y="1325880"/>
+            <a:ext cx="10866632" cy="4915191"/>
+          </a:xfrm>
+          <a:prstGeom prst="rect">
+            <a:avLst/>
+          </a:prstGeom>
+        </p:spPr>
+      </p:pic>
       <p:sp>
         <p:nvSpPr>
           <p:cNvPr id="2" name="Shape 0">
@@ -16165,7 +16073,7 @@
           <p:nvPr/>
         </p:nvPicPr>
         <p:blipFill>
-          <a:blip r:embed="rId3"/>
+          <a:blip r:embed="rId4"/>
           <a:srcRect b="-176"/>
           <a:stretch>
             <a:fillRect/>
@@ -16175,36 +16083,6 @@
           <a:xfrm>
             <a:off x="10792419" y="367621"/>
             <a:ext cx="852695" cy="852309"/>
-          </a:xfrm>
-          <a:prstGeom prst="rect">
-            <a:avLst/>
-          </a:prstGeom>
-        </p:spPr>
-      </p:pic>
-      <p:pic>
-        <p:nvPicPr>
-          <p:cNvPr id="10" name="Picture 9">
-            <a:extLst>
-              <a:ext uri="{FF2B5EF4-FFF2-40B4-BE49-F238E27FC236}">
-                <a16:creationId xmlns:a16="http://schemas.microsoft.com/office/drawing/2014/main" id="{C630E89D-1AD7-2F6B-F35A-58E0EE731A82}"/>
-              </a:ext>
-            </a:extLst>
-          </p:cNvPr>
-          <p:cNvPicPr>
-            <a:picLocks noChangeAspect="1"/>
-          </p:cNvPicPr>
-          <p:nvPr/>
-        </p:nvPicPr>
-        <p:blipFill>
-          <a:blip r:embed="rId4"/>
-          <a:stretch>
-            <a:fillRect/>
-          </a:stretch>
-        </p:blipFill>
-        <p:spPr>
-          <a:xfrm>
-            <a:off x="931945" y="1566754"/>
-            <a:ext cx="10328109" cy="4606241"/>
           </a:xfrm>
           <a:prstGeom prst="rect">
             <a:avLst/>
@@ -16507,8 +16385,8 @@
         </p:blipFill>
         <p:spPr>
           <a:xfrm>
-            <a:off x="1461478" y="1933111"/>
-            <a:ext cx="8972557" cy="4354328"/>
+            <a:off x="1462661" y="1818921"/>
+            <a:ext cx="9498931" cy="4609774"/>
           </a:xfrm>
           <a:prstGeom prst="rect">
             <a:avLst/>
@@ -16774,8 +16652,8 @@
         </p:blipFill>
         <p:spPr>
           <a:xfrm>
-            <a:off x="1245941" y="1711008"/>
-            <a:ext cx="9697069" cy="4580526"/>
+            <a:off x="982989" y="1459263"/>
+            <a:ext cx="10346168" cy="4887136"/>
           </a:xfrm>
           <a:prstGeom prst="rect">
             <a:avLst/>
@@ -17226,6 +17104,36 @@
           <a:chExt cx="0" cy="0"/>
         </a:xfrm>
       </p:grpSpPr>
+      <p:pic>
+        <p:nvPicPr>
+          <p:cNvPr id="9" name="Picture 8">
+            <a:extLst>
+              <a:ext uri="{FF2B5EF4-FFF2-40B4-BE49-F238E27FC236}">
+                <a16:creationId xmlns:a16="http://schemas.microsoft.com/office/drawing/2014/main" id="{73A65E77-5535-DD33-C841-CD8293CD02D6}"/>
+              </a:ext>
+            </a:extLst>
+          </p:cNvPr>
+          <p:cNvPicPr>
+            <a:picLocks noChangeAspect="1"/>
+          </p:cNvPicPr>
+          <p:nvPr/>
+        </p:nvPicPr>
+        <p:blipFill>
+          <a:blip r:embed="rId3"/>
+          <a:stretch>
+            <a:fillRect/>
+          </a:stretch>
+        </p:blipFill>
+        <p:spPr>
+          <a:xfrm>
+            <a:off x="1194321" y="1417320"/>
+            <a:ext cx="10037980" cy="4901646"/>
+          </a:xfrm>
+          <a:prstGeom prst="rect">
+            <a:avLst/>
+          </a:prstGeom>
+        </p:spPr>
+      </p:pic>
       <p:sp>
         <p:nvSpPr>
           <p:cNvPr id="2" name="Shape 0">
@@ -17396,7 +17304,7 @@
           <p:nvPr/>
         </p:nvPicPr>
         <p:blipFill>
-          <a:blip r:embed="rId3"/>
+          <a:blip r:embed="rId4"/>
           <a:srcRect b="-176"/>
           <a:stretch>
             <a:fillRect/>
@@ -17406,43 +17314,6 @@
           <a:xfrm>
             <a:off x="10792419" y="367621"/>
             <a:ext cx="852695" cy="852309"/>
-          </a:xfrm>
-          <a:prstGeom prst="rect">
-            <a:avLst/>
-          </a:prstGeom>
-        </p:spPr>
-      </p:pic>
-      <p:pic>
-        <p:nvPicPr>
-          <p:cNvPr id="5" name="Graphic 4">
-            <a:extLst>
-              <a:ext uri="{FF2B5EF4-FFF2-40B4-BE49-F238E27FC236}">
-                <a16:creationId xmlns:a16="http://schemas.microsoft.com/office/drawing/2014/main" id="{E8BA72EF-63AB-6900-ECBA-0613398FEF19}"/>
-              </a:ext>
-            </a:extLst>
-          </p:cNvPr>
-          <p:cNvPicPr>
-            <a:picLocks noChangeAspect="1"/>
-          </p:cNvPicPr>
-          <p:nvPr/>
-        </p:nvPicPr>
-        <p:blipFill>
-          <a:blip>
-            <a:extLst>
-              <a:ext uri="{96DAC541-7B7A-43D3-8B79-37D633B846F1}">
-                <asvg:svgBlip xmlns:asvg="http://schemas.microsoft.com/office/drawing/2016/SVG/main" r:embed="rId4"/>
-              </a:ext>
-            </a:extLst>
-          </a:blip>
-          <a:srcRect t="17199"/>
-          <a:stretch>
-            <a:fillRect/>
-          </a:stretch>
-        </p:blipFill>
-        <p:spPr>
-          <a:xfrm>
-            <a:off x="1090577" y="1634067"/>
-            <a:ext cx="10007797" cy="4657467"/>
           </a:xfrm>
           <a:prstGeom prst="rect">
             <a:avLst/>
@@ -19144,10 +19015,10 @@
       </p:pic>
       <p:pic>
         <p:nvPicPr>
-          <p:cNvPr id="8" name="Picture 7">
-            <a:extLst>
-              <a:ext uri="{FF2B5EF4-FFF2-40B4-BE49-F238E27FC236}">
-                <a16:creationId xmlns:a16="http://schemas.microsoft.com/office/drawing/2014/main" id="{33142B98-76D2-FA75-DDCA-FF984CAAAADB}"/>
+          <p:cNvPr id="10" name="Picture 9">
+            <a:extLst>
+              <a:ext uri="{FF2B5EF4-FFF2-40B4-BE49-F238E27FC236}">
+                <a16:creationId xmlns:a16="http://schemas.microsoft.com/office/drawing/2014/main" id="{8DC27062-2FCA-982A-FF3B-E24B57511596}"/>
               </a:ext>
             </a:extLst>
           </p:cNvPr>
@@ -19164,20 +19035,19 @@
         </p:blipFill>
         <p:spPr>
           <a:xfrm>
-            <a:off x="1093634" y="2639185"/>
-            <a:ext cx="10001684" cy="2817483"/>
+            <a:off x="731520" y="2659887"/>
+            <a:ext cx="10424564" cy="2872233"/>
           </a:xfrm>
           <a:prstGeom prst="rect">
             <a:avLst/>
           </a:prstGeom>
           <a:ln>
             <a:solidFill>
-              <a:schemeClr val="bg1">
-                <a:lumMod val="85000"/>
+              <a:schemeClr val="bg2">
+                <a:lumMod val="90000"/>
               </a:schemeClr>
             </a:solidFill>
           </a:ln>
-          <a:effectLst/>
         </p:spPr>
       </p:pic>
     </p:spTree>
@@ -19909,51 +19779,6 @@
           </a:p>
         </p:txBody>
       </p:sp>
-      <p:sp>
-        <p:nvSpPr>
-          <p:cNvPr id="11" name="Text 7">
-            <a:extLst>
-              <a:ext uri="{FF2B5EF4-FFF2-40B4-BE49-F238E27FC236}">
-                <a16:creationId xmlns:a16="http://schemas.microsoft.com/office/drawing/2014/main" id="{7D118E4F-2D67-E753-17E6-244B5916C1FA}"/>
-              </a:ext>
-            </a:extLst>
-          </p:cNvPr>
-          <p:cNvSpPr/>
-          <p:nvPr/>
-        </p:nvSpPr>
-        <p:spPr>
-          <a:xfrm>
-            <a:off x="0" y="6419088"/>
-            <a:ext cx="12191695" cy="320040"/>
-          </a:xfrm>
-          <a:prstGeom prst="rect">
-            <a:avLst/>
-          </a:prstGeom>
-          <a:noFill/>
-          <a:ln/>
-        </p:spPr>
-        <p:txBody>
-          <a:bodyPr wrap="square" lIns="0" tIns="0" rIns="0" bIns="0" rtlCol="0" anchor="ctr"/>
-          <a:lstStyle/>
-          <a:p>
-            <a:pPr marL="0" indent="0" algn="ctr">
-              <a:buNone/>
-            </a:pPr>
-            <a:r>
-              <a:rPr lang="en-US" sz="950" kern="0" spc="200">
-                <a:solidFill>
-                  <a:srgbClr val="8A93A8"/>
-                </a:solidFill>
-                <a:latin typeface="Arial" pitchFamily="34" charset="0"/>
-                <a:ea typeface="Arial" pitchFamily="34" charset="-122"/>
-                <a:cs typeface="Arial" pitchFamily="34" charset="-120"/>
-              </a:rPr>
-              <a:t>D A T A H A C K   S U M M I T   2 0 2 6</a:t>
-            </a:r>
-            <a:endParaRPr lang="en-US" sz="950"/>
-          </a:p>
-        </p:txBody>
-      </p:sp>
       <p:pic>
         <p:nvPicPr>
           <p:cNvPr id="12" name="Picture 11" descr="preencoded.png">
@@ -19985,86 +19810,204 @@
           </a:prstGeom>
         </p:spPr>
       </p:pic>
-      <p:pic>
-        <p:nvPicPr>
-          <p:cNvPr id="10" name="Picture 9">
-            <a:extLst>
-              <a:ext uri="{FF2B5EF4-FFF2-40B4-BE49-F238E27FC236}">
-                <a16:creationId xmlns:a16="http://schemas.microsoft.com/office/drawing/2014/main" id="{6657C89B-7FFF-D5D3-ABE1-8780D9EA01E1}"/>
-              </a:ext>
-            </a:extLst>
-          </p:cNvPr>
-          <p:cNvPicPr>
-            <a:picLocks noChangeAspect="1"/>
-          </p:cNvPicPr>
-          <p:nvPr/>
-        </p:nvPicPr>
-        <p:blipFill>
-          <a:blip r:embed="rId4"/>
-          <a:srcRect r="1534"/>
-          <a:stretch>
-            <a:fillRect/>
-          </a:stretch>
-        </p:blipFill>
-        <p:spPr>
-          <a:xfrm>
-            <a:off x="2073408" y="1669291"/>
-            <a:ext cx="8045183" cy="4714233"/>
-          </a:xfrm>
-          <a:prstGeom prst="rect">
-            <a:avLst/>
-          </a:prstGeom>
-          <a:ln>
+      <p:grpSp>
+        <p:nvGrpSpPr>
+          <p:cNvPr id="8" name="Group 7">
+            <a:extLst>
+              <a:ext uri="{FF2B5EF4-FFF2-40B4-BE49-F238E27FC236}">
+                <a16:creationId xmlns:a16="http://schemas.microsoft.com/office/drawing/2014/main" id="{F85C357F-592F-98A8-4F28-4A9AC348E093}"/>
+              </a:ext>
+            </a:extLst>
+          </p:cNvPr>
+          <p:cNvGrpSpPr/>
+          <p:nvPr/>
+        </p:nvGrpSpPr>
+        <p:grpSpPr>
+          <a:xfrm>
+            <a:off x="0" y="1417319"/>
+            <a:ext cx="12191695" cy="5321809"/>
+            <a:chOff x="0" y="1417319"/>
+            <a:chExt cx="12191695" cy="5321809"/>
+          </a:xfrm>
+        </p:grpSpPr>
+        <p:pic>
+          <p:nvPicPr>
+            <p:cNvPr id="6" name="Picture 5">
+              <a:extLst>
+                <a:ext uri="{FF2B5EF4-FFF2-40B4-BE49-F238E27FC236}">
+                  <a16:creationId xmlns:a16="http://schemas.microsoft.com/office/drawing/2014/main" id="{14F31690-9A8B-1438-1EF8-1A22A617B7A7}"/>
+                </a:ext>
+              </a:extLst>
+            </p:cNvPr>
+            <p:cNvPicPr>
+              <a:picLocks noChangeAspect="1"/>
+            </p:cNvPicPr>
+            <p:nvPr/>
+          </p:nvPicPr>
+          <p:blipFill>
+            <a:blip r:embed="rId4"/>
+            <a:stretch>
+              <a:fillRect/>
+            </a:stretch>
+          </p:blipFill>
+          <p:spPr>
+            <a:xfrm>
+              <a:off x="777279" y="1417319"/>
+              <a:ext cx="10867836" cy="5038345"/>
+            </a:xfrm>
+            <a:prstGeom prst="rect">
+              <a:avLst/>
+            </a:prstGeom>
+          </p:spPr>
+        </p:pic>
+        <p:sp>
+          <p:nvSpPr>
+            <p:cNvPr id="11" name="Text 7">
+              <a:extLst>
+                <a:ext uri="{FF2B5EF4-FFF2-40B4-BE49-F238E27FC236}">
+                  <a16:creationId xmlns:a16="http://schemas.microsoft.com/office/drawing/2014/main" id="{7D118E4F-2D67-E753-17E6-244B5916C1FA}"/>
+                </a:ext>
+              </a:extLst>
+            </p:cNvPr>
+            <p:cNvSpPr/>
+            <p:nvPr/>
+          </p:nvSpPr>
+          <p:spPr>
+            <a:xfrm>
+              <a:off x="0" y="6419088"/>
+              <a:ext cx="12191695" cy="320040"/>
+            </a:xfrm>
+            <a:prstGeom prst="rect">
+              <a:avLst/>
+            </a:prstGeom>
+            <a:noFill/>
+            <a:ln/>
+          </p:spPr>
+          <p:txBody>
+            <a:bodyPr wrap="square" lIns="0" tIns="0" rIns="0" bIns="0" rtlCol="0" anchor="ctr"/>
+            <a:lstStyle/>
+            <a:p>
+              <a:pPr marL="0" indent="0" algn="ctr">
+                <a:buNone/>
+              </a:pPr>
+              <a:r>
+                <a:rPr lang="en-US" sz="950" kern="0" spc="200">
+                  <a:solidFill>
+                    <a:srgbClr val="8A93A8"/>
+                  </a:solidFill>
+                  <a:latin typeface="Arial" pitchFamily="34" charset="0"/>
+                  <a:ea typeface="Arial" pitchFamily="34" charset="-122"/>
+                  <a:cs typeface="Arial" pitchFamily="34" charset="-120"/>
+                </a:rPr>
+                <a:t>D A T A H A C K   S U M M I T   2 0 2 6</a:t>
+              </a:r>
+              <a:endParaRPr lang="en-US" sz="950"/>
+            </a:p>
+          </p:txBody>
+        </p:sp>
+        <p:sp>
+          <p:nvSpPr>
+            <p:cNvPr id="13" name="Text 3">
+              <a:extLst>
+                <a:ext uri="{FF2B5EF4-FFF2-40B4-BE49-F238E27FC236}">
+                  <a16:creationId xmlns:a16="http://schemas.microsoft.com/office/drawing/2014/main" id="{453C5BBF-207D-99E3-0D67-8BD22CE7382B}"/>
+                </a:ext>
+              </a:extLst>
+            </p:cNvPr>
+            <p:cNvSpPr/>
+            <p:nvPr/>
+          </p:nvSpPr>
+          <p:spPr>
+            <a:xfrm>
+              <a:off x="512064" y="1417320"/>
+              <a:ext cx="8686800" cy="411480"/>
+            </a:xfrm>
+            <a:prstGeom prst="rect">
+              <a:avLst/>
+            </a:prstGeom>
+            <a:noFill/>
+            <a:ln/>
+          </p:spPr>
+          <p:txBody>
+            <a:bodyPr wrap="square" lIns="0" tIns="0" rIns="0" bIns="0" rtlCol="0" anchor="ctr"/>
+            <a:lstStyle/>
+            <a:p>
+              <a:pPr marL="0" indent="0">
+                <a:buNone/>
+              </a:pPr>
+              <a:r>
+                <a:rPr lang="en-US" sz="1350" i="1" dirty="0">
+                  <a:solidFill>
+                    <a:srgbClr val="8A93A8"/>
+                  </a:solidFill>
+                  <a:latin typeface="Calibri" pitchFamily="34" charset="0"/>
+                  <a:ea typeface="Calibri" pitchFamily="34" charset="-122"/>
+                  <a:cs typeface="Calibri" pitchFamily="34" charset="-120"/>
+                </a:rPr>
+                <a:t>AOE matrix for traditional ML vs Agentic Systems</a:t>
+              </a:r>
+            </a:p>
+          </p:txBody>
+        </p:sp>
+        <p:sp>
+          <p:nvSpPr>
+            <p:cNvPr id="7" name="Rectangle 6">
+              <a:extLst>
+                <a:ext uri="{FF2B5EF4-FFF2-40B4-BE49-F238E27FC236}">
+                  <a16:creationId xmlns:a16="http://schemas.microsoft.com/office/drawing/2014/main" id="{8B855BC1-27E3-DF55-C64B-3A2D3D28D99D}"/>
+                </a:ext>
+              </a:extLst>
+            </p:cNvPr>
+            <p:cNvSpPr/>
+            <p:nvPr/>
+          </p:nvSpPr>
+          <p:spPr>
+            <a:xfrm>
+              <a:off x="8655627" y="3730336"/>
+              <a:ext cx="2774373" cy="1531205"/>
+            </a:xfrm>
+            <a:prstGeom prst="rect">
+              <a:avLst/>
+            </a:prstGeom>
             <a:solidFill>
               <a:schemeClr val="bg1"/>
             </a:solidFill>
-          </a:ln>
-        </p:spPr>
-      </p:pic>
-      <p:sp>
-        <p:nvSpPr>
-          <p:cNvPr id="13" name="Text 3">
-            <a:extLst>
-              <a:ext uri="{FF2B5EF4-FFF2-40B4-BE49-F238E27FC236}">
-                <a16:creationId xmlns:a16="http://schemas.microsoft.com/office/drawing/2014/main" id="{453C5BBF-207D-99E3-0D67-8BD22CE7382B}"/>
-              </a:ext>
-            </a:extLst>
-          </p:cNvPr>
-          <p:cNvSpPr/>
-          <p:nvPr/>
-        </p:nvSpPr>
-        <p:spPr>
-          <a:xfrm>
-            <a:off x="512064" y="1417320"/>
-            <a:ext cx="8686800" cy="411480"/>
-          </a:xfrm>
-          <a:prstGeom prst="rect">
-            <a:avLst/>
-          </a:prstGeom>
-          <a:noFill/>
-          <a:ln/>
-        </p:spPr>
-        <p:txBody>
-          <a:bodyPr wrap="square" lIns="0" tIns="0" rIns="0" bIns="0" rtlCol="0" anchor="ctr"/>
-          <a:lstStyle/>
-          <a:p>
-            <a:pPr marL="0" indent="0">
-              <a:buNone/>
-            </a:pPr>
-            <a:r>
-              <a:rPr lang="en-US" sz="1350" i="1" dirty="0">
-                <a:solidFill>
-                  <a:srgbClr val="8A93A8"/>
-                </a:solidFill>
-                <a:latin typeface="Calibri" pitchFamily="34" charset="0"/>
-                <a:ea typeface="Calibri" pitchFamily="34" charset="-122"/>
-                <a:cs typeface="Calibri" pitchFamily="34" charset="-120"/>
-              </a:rPr>
-              <a:t>AOE matrix for traditional ML vs Agentic Systems</a:t>
-            </a:r>
-          </a:p>
-        </p:txBody>
-      </p:sp>
+            <a:ln>
+              <a:solidFill>
+                <a:schemeClr val="bg1"/>
+              </a:solidFill>
+            </a:ln>
+          </p:spPr>
+          <p:style>
+            <a:lnRef idx="2">
+              <a:schemeClr val="accent1">
+                <a:shade val="15000"/>
+              </a:schemeClr>
+            </a:lnRef>
+            <a:fillRef idx="1">
+              <a:schemeClr val="accent1"/>
+            </a:fillRef>
+            <a:effectRef idx="0">
+              <a:schemeClr val="accent1"/>
+            </a:effectRef>
+            <a:fontRef idx="minor">
+              <a:schemeClr val="lt1"/>
+            </a:fontRef>
+          </p:style>
+          <p:txBody>
+            <a:bodyPr rtlCol="0" anchor="ctr"/>
+            <a:lstStyle/>
+            <a:p>
+              <a:pPr algn="ctr"/>
+              <a:endParaRPr lang="en-IN">
+                <a:solidFill>
+                  <a:schemeClr val="bg1"/>
+                </a:solidFill>
+              </a:endParaRPr>
+            </a:p>
+          </p:txBody>
+        </p:sp>
+      </p:grpSp>
     </p:spTree>
     <p:extLst>
       <p:ext uri="{BB962C8B-B14F-4D97-AF65-F5344CB8AC3E}">
@@ -20081,20 +20024,12 @@
 <file path=ppt/slides/slide9.xml><?xml version="1.0" encoding="utf-8"?>
 <p:sld xmlns:a="http://schemas.openxmlformats.org/drawingml/2006/main" xmlns:r="http://schemas.openxmlformats.org/officeDocument/2006/relationships" xmlns:p="http://schemas.openxmlformats.org/presentationml/2006/main">
   <p:cSld>
-    <p:bg>
-      <p:bgPr>
-        <a:solidFill>
-          <a:srgbClr val="FFFFFF"/>
-        </a:solidFill>
-        <a:effectLst/>
-      </p:bgPr>
-    </p:bg>
     <p:spTree>
       <p:nvGrpSpPr>
         <p:cNvPr id="1" name="">
           <a:extLst>
             <a:ext uri="{FF2B5EF4-FFF2-40B4-BE49-F238E27FC236}">
-              <a16:creationId xmlns:a16="http://schemas.microsoft.com/office/drawing/2014/main" id="{1B538772-4352-E65F-2D91-B2B6DD94FACB}"/>
+              <a16:creationId xmlns:a16="http://schemas.microsoft.com/office/drawing/2014/main" id="{70CA5800-842C-DEE4-C577-A7BEC75238B6}"/>
             </a:ext>
           </a:extLst>
         </p:cNvPr>
@@ -20109,12 +20044,42 @@
           <a:chExt cx="0" cy="0"/>
         </a:xfrm>
       </p:grpSpPr>
+      <p:pic>
+        <p:nvPicPr>
+          <p:cNvPr id="6" name="Picture 5">
+            <a:extLst>
+              <a:ext uri="{FF2B5EF4-FFF2-40B4-BE49-F238E27FC236}">
+                <a16:creationId xmlns:a16="http://schemas.microsoft.com/office/drawing/2014/main" id="{E3CEC2B6-4719-83B2-B40C-249162136B5F}"/>
+              </a:ext>
+            </a:extLst>
+          </p:cNvPr>
+          <p:cNvPicPr>
+            <a:picLocks noChangeAspect="1"/>
+          </p:cNvPicPr>
+          <p:nvPr/>
+        </p:nvPicPr>
+        <p:blipFill>
+          <a:blip r:embed="rId3"/>
+          <a:stretch>
+            <a:fillRect/>
+          </a:stretch>
+        </p:blipFill>
+        <p:spPr>
+          <a:xfrm>
+            <a:off x="777279" y="1417319"/>
+            <a:ext cx="10867836" cy="5038345"/>
+          </a:xfrm>
+          <a:prstGeom prst="rect">
+            <a:avLst/>
+          </a:prstGeom>
+        </p:spPr>
+      </p:pic>
       <p:sp>
         <p:nvSpPr>
           <p:cNvPr id="2" name="Shape 0">
             <a:extLst>
               <a:ext uri="{FF2B5EF4-FFF2-40B4-BE49-F238E27FC236}">
-                <a16:creationId xmlns:a16="http://schemas.microsoft.com/office/drawing/2014/main" id="{69B9852F-CD39-A987-0B9D-4EDBD36FC9AE}"/>
+                <a16:creationId xmlns:a16="http://schemas.microsoft.com/office/drawing/2014/main" id="{01897F1A-4A8C-CD14-A3E7-19BB345C8F20}"/>
               </a:ext>
             </a:extLst>
           </p:cNvPr>
@@ -20147,7 +20112,7 @@
           <p:cNvPr id="3" name="Text 1">
             <a:extLst>
               <a:ext uri="{FF2B5EF4-FFF2-40B4-BE49-F238E27FC236}">
-                <a16:creationId xmlns:a16="http://schemas.microsoft.com/office/drawing/2014/main" id="{063C5B6C-6108-E456-9A46-F554927AEBA3}"/>
+                <a16:creationId xmlns:a16="http://schemas.microsoft.com/office/drawing/2014/main" id="{D74674E5-792D-D10F-9596-F47AA8E3457A}"/>
               </a:ext>
             </a:extLst>
           </p:cNvPr>
@@ -20191,7 +20156,7 @@
           <p:cNvPr id="4" name="Shape 2">
             <a:extLst>
               <a:ext uri="{FF2B5EF4-FFF2-40B4-BE49-F238E27FC236}">
-                <a16:creationId xmlns:a16="http://schemas.microsoft.com/office/drawing/2014/main" id="{A6D4DF15-0FA1-BA13-FBEF-20EA7F4A72A0}"/>
+                <a16:creationId xmlns:a16="http://schemas.microsoft.com/office/drawing/2014/main" id="{5FFF4FBE-E7ED-7516-ED02-332CEC73BB51}"/>
               </a:ext>
             </a:extLst>
           </p:cNvPr>
@@ -20224,7 +20189,7 @@
           <p:cNvPr id="11" name="Text 7">
             <a:extLst>
               <a:ext uri="{FF2B5EF4-FFF2-40B4-BE49-F238E27FC236}">
-                <a16:creationId xmlns:a16="http://schemas.microsoft.com/office/drawing/2014/main" id="{06D13C82-5EF0-FA4A-2BE9-BFD80BFD6CD0}"/>
+                <a16:creationId xmlns:a16="http://schemas.microsoft.com/office/drawing/2014/main" id="{B959B7AA-65A4-673F-CDFA-F8EAAA4B5427}"/>
               </a:ext>
             </a:extLst>
           </p:cNvPr>
@@ -20269,7 +20234,7 @@
           <p:cNvPr id="12" name="Picture 11" descr="preencoded.png">
             <a:extLst>
               <a:ext uri="{FF2B5EF4-FFF2-40B4-BE49-F238E27FC236}">
-                <a16:creationId xmlns:a16="http://schemas.microsoft.com/office/drawing/2014/main" id="{2400D10B-23B4-5478-6241-7A210A43E674}"/>
+                <a16:creationId xmlns:a16="http://schemas.microsoft.com/office/drawing/2014/main" id="{1A4BDE44-2CD3-EAF1-C257-3C4A2E3924F5}"/>
               </a:ext>
             </a:extLst>
           </p:cNvPr>
@@ -20279,7 +20244,7 @@
           <p:nvPr/>
         </p:nvPicPr>
         <p:blipFill>
-          <a:blip r:embed="rId3"/>
+          <a:blip r:embed="rId4"/>
           <a:srcRect b="-176"/>
           <a:stretch>
             <a:fillRect/>
@@ -20295,48 +20260,12 @@
           </a:prstGeom>
         </p:spPr>
       </p:pic>
-      <p:pic>
-        <p:nvPicPr>
-          <p:cNvPr id="10" name="Picture 9">
-            <a:extLst>
-              <a:ext uri="{FF2B5EF4-FFF2-40B4-BE49-F238E27FC236}">
-                <a16:creationId xmlns:a16="http://schemas.microsoft.com/office/drawing/2014/main" id="{E81CBC70-8988-9453-2975-23F34AA12B97}"/>
-              </a:ext>
-            </a:extLst>
-          </p:cNvPr>
-          <p:cNvPicPr>
-            <a:picLocks noChangeAspect="1"/>
-          </p:cNvPicPr>
-          <p:nvPr/>
-        </p:nvPicPr>
-        <p:blipFill>
-          <a:blip r:embed="rId4"/>
-          <a:srcRect r="1534"/>
-          <a:stretch>
-            <a:fillRect/>
-          </a:stretch>
-        </p:blipFill>
-        <p:spPr>
-          <a:xfrm>
-            <a:off x="2073408" y="1669291"/>
-            <a:ext cx="8045183" cy="4714233"/>
-          </a:xfrm>
-          <a:prstGeom prst="rect">
-            <a:avLst/>
-          </a:prstGeom>
-          <a:ln>
-            <a:solidFill>
-              <a:schemeClr val="bg1"/>
-            </a:solidFill>
-          </a:ln>
-        </p:spPr>
-      </p:pic>
       <p:sp>
         <p:nvSpPr>
           <p:cNvPr id="13" name="Text 3">
             <a:extLst>
               <a:ext uri="{FF2B5EF4-FFF2-40B4-BE49-F238E27FC236}">
-                <a16:creationId xmlns:a16="http://schemas.microsoft.com/office/drawing/2014/main" id="{D8D84158-A2F4-BA57-2E0E-AE2B9D89F996}"/>
+                <a16:creationId xmlns:a16="http://schemas.microsoft.com/office/drawing/2014/main" id="{9BBC1E1B-7C3E-0AB8-3A88-A71CC18E8BD9}"/>
               </a:ext>
             </a:extLst>
           </p:cNvPr>
@@ -20377,20 +20306,20 @@
       </p:sp>
       <p:sp>
         <p:nvSpPr>
-          <p:cNvPr id="16" name="Rounded Rectangle 15">
-            <a:extLst>
-              <a:ext uri="{FF2B5EF4-FFF2-40B4-BE49-F238E27FC236}">
-                <a16:creationId xmlns:a16="http://schemas.microsoft.com/office/drawing/2014/main" id="{312BD5A2-20D5-AB0F-0D9E-CB91238BD82E}"/>
-              </a:ext>
-            </a:extLst>
-          </p:cNvPr>
-          <p:cNvSpPr/>
-          <p:nvPr/>
-        </p:nvSpPr>
-        <p:spPr>
-          <a:xfrm>
-            <a:off x="1994744" y="3740725"/>
-            <a:ext cx="8174182" cy="1524279"/>
+          <p:cNvPr id="7" name="Rounded Rectangle 15">
+            <a:extLst>
+              <a:ext uri="{FF2B5EF4-FFF2-40B4-BE49-F238E27FC236}">
+                <a16:creationId xmlns:a16="http://schemas.microsoft.com/office/drawing/2014/main" id="{344CD104-30E3-B7E4-22D4-6F09900C4DA9}"/>
+              </a:ext>
+            </a:extLst>
+          </p:cNvPr>
+          <p:cNvSpPr/>
+          <p:nvPr/>
+        </p:nvSpPr>
+        <p:spPr>
+          <a:xfrm>
+            <a:off x="1194955" y="3688773"/>
+            <a:ext cx="10219766" cy="1751907"/>
           </a:xfrm>
           <a:prstGeom prst="roundRect">
             <a:avLst>
@@ -20430,7 +20359,7 @@
     </p:spTree>
     <p:extLst>
       <p:ext uri="{BB962C8B-B14F-4D97-AF65-F5344CB8AC3E}">
-        <p14:creationId xmlns:p14="http://schemas.microsoft.com/office/powerpoint/2010/main" val="3986384036"/>
+        <p14:creationId xmlns:p14="http://schemas.microsoft.com/office/powerpoint/2010/main" val="2428407563"/>
       </p:ext>
     </p:extLst>
   </p:cSld>

</xml_diff>